<commit_message>
fix: LLM 提取后也生成 template_design.json + 恢复误删的 template.pptx
</commit_message>
<xml_diff>
--- a/demo/demo2/template.pptx
+++ b/demo/demo2/template.pptx
@@ -1,16 +1,16 @@
 
 <file path=ppt/presentation.xml><?xml version="1.0" encoding="utf-8"?>
-<p:presentation xmlns:a="http://schemas.openxmlformats.org/drawingml/2006/main" xmlns:r="http://schemas.openxmlformats.org/officeDocument/2006/relationships" xmlns:p="http://schemas.openxmlformats.org/presentationml/2006/main" saveSubsetFonts="1" autoCompressPictures="0">
+<p:presentation xmlns:a="http://schemas.openxmlformats.org/drawingml/2006/main" xmlns:r="http://schemas.openxmlformats.org/officeDocument/2006/relationships" xmlns:p="http://schemas.openxmlformats.org/presentationml/2006/main" autoCompressPictures="0">
   <p:sldMasterIdLst>
     <p:sldMasterId id="2147483648" r:id="rId1"/>
   </p:sldMasterIdLst>
   <p:sldIdLst>
-    <p:sldId id="256" r:id="rId7"/>
-    <p:sldId id="257" r:id="rId8"/>
-    <p:sldId id="258" r:id="rId9"/>
-    <p:sldId id="263" r:id="rId14"/>
+    <p:sldId id="256" r:id="rId3"/>
+    <p:sldId id="257" r:id="rId4"/>
+    <p:sldId id="258" r:id="rId5"/>
+    <p:sldId id="286" r:id="rId11"/>
   </p:sldIdLst>
-  <p:sldSz cx="12191695" cy="6858000" type="screen4x3"/>
+  <p:sldSz cx="12191365" cy="6858000" type="screen4x3"/>
   <p:notesSz cx="6858000" cy="9144000"/>
   <p:defaultTextStyle>
     <a:defPPr>
@@ -107,6 +107,22 @@
       </a:defRPr>
     </a:lvl9pPr>
   </p:defaultTextStyle>
+  <p:extLst>
+    <p:ext uri="{EFAFB233-063F-42B5-8137-9DF3F51BA10A}">
+      <p15:sldGuideLst xmlns:p15="http://schemas.microsoft.com/office/powerpoint/2012/main">
+        <p15:guide id="1" orient="horz" pos="2160" userDrawn="1">
+          <p15:clr>
+            <a:srgbClr val="A4A3A4"/>
+          </p15:clr>
+        </p15:guide>
+        <p15:guide id="2" pos="2880" userDrawn="1">
+          <p15:clr>
+            <a:srgbClr val="A4A3A4"/>
+          </p15:clr>
+        </p15:guide>
+      </p15:sldGuideLst>
+    </p:ext>
+  </p:extLst>
 </p:presentation>
 </file>
 
@@ -291,7 +307,6 @@
           <a:p>
             <a:fld id="{5BCAD085-E8A6-8845-BD4E-CB4CCA059FC4}" type="datetimeFigureOut">
               <a:rPr lang="en-US" smtClean="0"/>
-              <a:t>1/27/13</a:t>
             </a:fld>
             <a:endParaRPr lang="en-US"/>
           </a:p>
@@ -333,18 +348,12 @@
           <a:p>
             <a:fld id="{C1FF6DA9-008F-8B48-92A6-B652298478BF}" type="slidenum">
               <a:rPr lang="en-US" smtClean="0"/>
-              <a:t>‹#›</a:t>
             </a:fld>
             <a:endParaRPr lang="en-US"/>
           </a:p>
         </p:txBody>
       </p:sp>
     </p:spTree>
-    <p:extLst>
-      <p:ext uri="{BB962C8B-B14F-4D97-AF65-F5344CB8AC3E}">
-        <p14:creationId xmlns:p14="http://schemas.microsoft.com/office/powerpoint/2010/main" val="3168075583"/>
-      </p:ext>
-    </p:extLst>
   </p:cSld>
   <p:clrMapOvr>
     <a:masterClrMapping/>
@@ -412,6 +421,7 @@
               <a:rPr lang="en-US" smtClean="0"/>
               <a:t>Click to edit Master text styles</a:t>
             </a:r>
+            <a:endParaRPr lang="en-US" smtClean="0"/>
           </a:p>
           <a:p>
             <a:pPr lvl="1"/>
@@ -419,6 +429,7 @@
               <a:rPr lang="en-US" smtClean="0"/>
               <a:t>Second level</a:t>
             </a:r>
+            <a:endParaRPr lang="en-US" smtClean="0"/>
           </a:p>
           <a:p>
             <a:pPr lvl="2"/>
@@ -426,6 +437,7 @@
               <a:rPr lang="en-US" smtClean="0"/>
               <a:t>Third level</a:t>
             </a:r>
+            <a:endParaRPr lang="en-US" smtClean="0"/>
           </a:p>
           <a:p>
             <a:pPr lvl="3"/>
@@ -433,6 +445,7 @@
               <a:rPr lang="en-US" smtClean="0"/>
               <a:t>Fourth level</a:t>
             </a:r>
+            <a:endParaRPr lang="en-US" smtClean="0"/>
           </a:p>
           <a:p>
             <a:pPr lvl="4"/>
@@ -461,7 +474,6 @@
           <a:p>
             <a:fld id="{5BCAD085-E8A6-8845-BD4E-CB4CCA059FC4}" type="datetimeFigureOut">
               <a:rPr lang="en-US" smtClean="0"/>
-              <a:t>1/27/13</a:t>
             </a:fld>
             <a:endParaRPr lang="en-US"/>
           </a:p>
@@ -503,18 +515,12 @@
           <a:p>
             <a:fld id="{C1FF6DA9-008F-8B48-92A6-B652298478BF}" type="slidenum">
               <a:rPr lang="en-US" smtClean="0"/>
-              <a:t>‹#›</a:t>
             </a:fld>
             <a:endParaRPr lang="en-US"/>
           </a:p>
         </p:txBody>
       </p:sp>
     </p:spTree>
-    <p:extLst>
-      <p:ext uri="{BB962C8B-B14F-4D97-AF65-F5344CB8AC3E}">
-        <p14:creationId xmlns:p14="http://schemas.microsoft.com/office/powerpoint/2010/main" val="2910927964"/>
-      </p:ext>
-    </p:extLst>
   </p:cSld>
   <p:clrMapOvr>
     <a:masterClrMapping/>
@@ -592,6 +598,7 @@
               <a:rPr lang="en-US" smtClean="0"/>
               <a:t>Click to edit Master text styles</a:t>
             </a:r>
+            <a:endParaRPr lang="en-US" smtClean="0"/>
           </a:p>
           <a:p>
             <a:pPr lvl="1"/>
@@ -599,6 +606,7 @@
               <a:rPr lang="en-US" smtClean="0"/>
               <a:t>Second level</a:t>
             </a:r>
+            <a:endParaRPr lang="en-US" smtClean="0"/>
           </a:p>
           <a:p>
             <a:pPr lvl="2"/>
@@ -606,6 +614,7 @@
               <a:rPr lang="en-US" smtClean="0"/>
               <a:t>Third level</a:t>
             </a:r>
+            <a:endParaRPr lang="en-US" smtClean="0"/>
           </a:p>
           <a:p>
             <a:pPr lvl="3"/>
@@ -613,6 +622,7 @@
               <a:rPr lang="en-US" smtClean="0"/>
               <a:t>Fourth level</a:t>
             </a:r>
+            <a:endParaRPr lang="en-US" smtClean="0"/>
           </a:p>
           <a:p>
             <a:pPr lvl="4"/>
@@ -641,7 +651,6 @@
           <a:p>
             <a:fld id="{5BCAD085-E8A6-8845-BD4E-CB4CCA059FC4}" type="datetimeFigureOut">
               <a:rPr lang="en-US" smtClean="0"/>
-              <a:t>1/27/13</a:t>
             </a:fld>
             <a:endParaRPr lang="en-US"/>
           </a:p>
@@ -683,18 +692,12 @@
           <a:p>
             <a:fld id="{C1FF6DA9-008F-8B48-92A6-B652298478BF}" type="slidenum">
               <a:rPr lang="en-US" smtClean="0"/>
-              <a:t>‹#›</a:t>
             </a:fld>
             <a:endParaRPr lang="en-US"/>
           </a:p>
         </p:txBody>
       </p:sp>
     </p:spTree>
-    <p:extLst>
-      <p:ext uri="{BB962C8B-B14F-4D97-AF65-F5344CB8AC3E}">
-        <p14:creationId xmlns:p14="http://schemas.microsoft.com/office/powerpoint/2010/main" val="3612223792"/>
-      </p:ext>
-    </p:extLst>
   </p:cSld>
   <p:clrMapOvr>
     <a:masterClrMapping/>
@@ -762,6 +765,7 @@
               <a:rPr lang="en-US" smtClean="0"/>
               <a:t>Click to edit Master text styles</a:t>
             </a:r>
+            <a:endParaRPr lang="en-US" smtClean="0"/>
           </a:p>
           <a:p>
             <a:pPr lvl="1"/>
@@ -769,6 +773,7 @@
               <a:rPr lang="en-US" smtClean="0"/>
               <a:t>Second level</a:t>
             </a:r>
+            <a:endParaRPr lang="en-US" smtClean="0"/>
           </a:p>
           <a:p>
             <a:pPr lvl="2"/>
@@ -776,6 +781,7 @@
               <a:rPr lang="en-US" smtClean="0"/>
               <a:t>Third level</a:t>
             </a:r>
+            <a:endParaRPr lang="en-US" smtClean="0"/>
           </a:p>
           <a:p>
             <a:pPr lvl="3"/>
@@ -783,6 +789,7 @@
               <a:rPr lang="en-US" smtClean="0"/>
               <a:t>Fourth level</a:t>
             </a:r>
+            <a:endParaRPr lang="en-US" smtClean="0"/>
           </a:p>
           <a:p>
             <a:pPr lvl="4"/>
@@ -811,7 +818,6 @@
           <a:p>
             <a:fld id="{5BCAD085-E8A6-8845-BD4E-CB4CCA059FC4}" type="datetimeFigureOut">
               <a:rPr lang="en-US" smtClean="0"/>
-              <a:t>1/27/13</a:t>
             </a:fld>
             <a:endParaRPr lang="en-US"/>
           </a:p>
@@ -853,18 +859,12 @@
           <a:p>
             <a:fld id="{C1FF6DA9-008F-8B48-92A6-B652298478BF}" type="slidenum">
               <a:rPr lang="en-US" smtClean="0"/>
-              <a:t>‹#›</a:t>
             </a:fld>
             <a:endParaRPr lang="en-US"/>
           </a:p>
         </p:txBody>
       </p:sp>
     </p:spTree>
-    <p:extLst>
-      <p:ext uri="{BB962C8B-B14F-4D97-AF65-F5344CB8AC3E}">
-        <p14:creationId xmlns:p14="http://schemas.microsoft.com/office/powerpoint/2010/main" val="2614314258"/>
-      </p:ext>
-    </p:extLst>
   </p:cSld>
   <p:clrMapOvr>
     <a:masterClrMapping/>
@@ -1037,6 +1037,7 @@
               <a:rPr lang="en-US" smtClean="0"/>
               <a:t>Click to edit Master text styles</a:t>
             </a:r>
+            <a:endParaRPr lang="en-US" smtClean="0"/>
           </a:p>
         </p:txBody>
       </p:sp>
@@ -1057,7 +1058,6 @@
           <a:p>
             <a:fld id="{5BCAD085-E8A6-8845-BD4E-CB4CCA059FC4}" type="datetimeFigureOut">
               <a:rPr lang="en-US" smtClean="0"/>
-              <a:t>1/27/13</a:t>
             </a:fld>
             <a:endParaRPr lang="en-US"/>
           </a:p>
@@ -1099,18 +1099,12 @@
           <a:p>
             <a:fld id="{C1FF6DA9-008F-8B48-92A6-B652298478BF}" type="slidenum">
               <a:rPr lang="en-US" smtClean="0"/>
-              <a:t>‹#›</a:t>
             </a:fld>
             <a:endParaRPr lang="en-US"/>
           </a:p>
         </p:txBody>
       </p:sp>
     </p:spTree>
-    <p:extLst>
-      <p:ext uri="{BB962C8B-B14F-4D97-AF65-F5344CB8AC3E}">
-        <p14:creationId xmlns:p14="http://schemas.microsoft.com/office/powerpoint/2010/main" val="960648375"/>
-      </p:ext>
-    </p:extLst>
   </p:cSld>
   <p:clrMapOvr>
     <a:masterClrMapping/>
@@ -1211,6 +1205,7 @@
               <a:rPr lang="en-US" smtClean="0"/>
               <a:t>Click to edit Master text styles</a:t>
             </a:r>
+            <a:endParaRPr lang="en-US" smtClean="0"/>
           </a:p>
           <a:p>
             <a:pPr lvl="1"/>
@@ -1218,6 +1213,7 @@
               <a:rPr lang="en-US" smtClean="0"/>
               <a:t>Second level</a:t>
             </a:r>
+            <a:endParaRPr lang="en-US" smtClean="0"/>
           </a:p>
           <a:p>
             <a:pPr lvl="2"/>
@@ -1225,6 +1221,7 @@
               <a:rPr lang="en-US" smtClean="0"/>
               <a:t>Third level</a:t>
             </a:r>
+            <a:endParaRPr lang="en-US" smtClean="0"/>
           </a:p>
           <a:p>
             <a:pPr lvl="3"/>
@@ -1232,6 +1229,7 @@
               <a:rPr lang="en-US" smtClean="0"/>
               <a:t>Fourth level</a:t>
             </a:r>
+            <a:endParaRPr lang="en-US" smtClean="0"/>
           </a:p>
           <a:p>
             <a:pPr lvl="4"/>
@@ -1296,6 +1294,7 @@
               <a:rPr lang="en-US" smtClean="0"/>
               <a:t>Click to edit Master text styles</a:t>
             </a:r>
+            <a:endParaRPr lang="en-US" smtClean="0"/>
           </a:p>
           <a:p>
             <a:pPr lvl="1"/>
@@ -1303,6 +1302,7 @@
               <a:rPr lang="en-US" smtClean="0"/>
               <a:t>Second level</a:t>
             </a:r>
+            <a:endParaRPr lang="en-US" smtClean="0"/>
           </a:p>
           <a:p>
             <a:pPr lvl="2"/>
@@ -1310,6 +1310,7 @@
               <a:rPr lang="en-US" smtClean="0"/>
               <a:t>Third level</a:t>
             </a:r>
+            <a:endParaRPr lang="en-US" smtClean="0"/>
           </a:p>
           <a:p>
             <a:pPr lvl="3"/>
@@ -1317,6 +1318,7 @@
               <a:rPr lang="en-US" smtClean="0"/>
               <a:t>Fourth level</a:t>
             </a:r>
+            <a:endParaRPr lang="en-US" smtClean="0"/>
           </a:p>
           <a:p>
             <a:pPr lvl="4"/>
@@ -1345,7 +1347,6 @@
           <a:p>
             <a:fld id="{5BCAD085-E8A6-8845-BD4E-CB4CCA059FC4}" type="datetimeFigureOut">
               <a:rPr lang="en-US" smtClean="0"/>
-              <a:t>1/27/13</a:t>
             </a:fld>
             <a:endParaRPr lang="en-US"/>
           </a:p>
@@ -1387,18 +1388,12 @@
           <a:p>
             <a:fld id="{C1FF6DA9-008F-8B48-92A6-B652298478BF}" type="slidenum">
               <a:rPr lang="en-US" smtClean="0"/>
-              <a:t>‹#›</a:t>
             </a:fld>
             <a:endParaRPr lang="en-US"/>
           </a:p>
         </p:txBody>
       </p:sp>
     </p:spTree>
-    <p:extLst>
-      <p:ext uri="{BB962C8B-B14F-4D97-AF65-F5344CB8AC3E}">
-        <p14:creationId xmlns:p14="http://schemas.microsoft.com/office/powerpoint/2010/main" val="2782244947"/>
-      </p:ext>
-    </p:extLst>
   </p:cSld>
   <p:clrMapOvr>
     <a:masterClrMapping/>
@@ -1512,6 +1507,7 @@
               <a:rPr lang="en-US" smtClean="0"/>
               <a:t>Click to edit Master text styles</a:t>
             </a:r>
+            <a:endParaRPr lang="en-US" smtClean="0"/>
           </a:p>
         </p:txBody>
       </p:sp>
@@ -1568,6 +1564,7 @@
               <a:rPr lang="en-US" smtClean="0"/>
               <a:t>Click to edit Master text styles</a:t>
             </a:r>
+            <a:endParaRPr lang="en-US" smtClean="0"/>
           </a:p>
           <a:p>
             <a:pPr lvl="1"/>
@@ -1575,6 +1572,7 @@
               <a:rPr lang="en-US" smtClean="0"/>
               <a:t>Second level</a:t>
             </a:r>
+            <a:endParaRPr lang="en-US" smtClean="0"/>
           </a:p>
           <a:p>
             <a:pPr lvl="2"/>
@@ -1582,6 +1580,7 @@
               <a:rPr lang="en-US" smtClean="0"/>
               <a:t>Third level</a:t>
             </a:r>
+            <a:endParaRPr lang="en-US" smtClean="0"/>
           </a:p>
           <a:p>
             <a:pPr lvl="3"/>
@@ -1589,6 +1588,7 @@
               <a:rPr lang="en-US" smtClean="0"/>
               <a:t>Fourth level</a:t>
             </a:r>
+            <a:endParaRPr lang="en-US" smtClean="0"/>
           </a:p>
           <a:p>
             <a:pPr lvl="4"/>
@@ -1662,6 +1662,7 @@
               <a:rPr lang="en-US" smtClean="0"/>
               <a:t>Click to edit Master text styles</a:t>
             </a:r>
+            <a:endParaRPr lang="en-US" smtClean="0"/>
           </a:p>
         </p:txBody>
       </p:sp>
@@ -1718,6 +1719,7 @@
               <a:rPr lang="en-US" smtClean="0"/>
               <a:t>Click to edit Master text styles</a:t>
             </a:r>
+            <a:endParaRPr lang="en-US" smtClean="0"/>
           </a:p>
           <a:p>
             <a:pPr lvl="1"/>
@@ -1725,6 +1727,7 @@
               <a:rPr lang="en-US" smtClean="0"/>
               <a:t>Second level</a:t>
             </a:r>
+            <a:endParaRPr lang="en-US" smtClean="0"/>
           </a:p>
           <a:p>
             <a:pPr lvl="2"/>
@@ -1732,6 +1735,7 @@
               <a:rPr lang="en-US" smtClean="0"/>
               <a:t>Third level</a:t>
             </a:r>
+            <a:endParaRPr lang="en-US" smtClean="0"/>
           </a:p>
           <a:p>
             <a:pPr lvl="3"/>
@@ -1739,6 +1743,7 @@
               <a:rPr lang="en-US" smtClean="0"/>
               <a:t>Fourth level</a:t>
             </a:r>
+            <a:endParaRPr lang="en-US" smtClean="0"/>
           </a:p>
           <a:p>
             <a:pPr lvl="4"/>
@@ -1767,7 +1772,6 @@
           <a:p>
             <a:fld id="{5BCAD085-E8A6-8845-BD4E-CB4CCA059FC4}" type="datetimeFigureOut">
               <a:rPr lang="en-US" smtClean="0"/>
-              <a:t>1/27/13</a:t>
             </a:fld>
             <a:endParaRPr lang="en-US"/>
           </a:p>
@@ -1809,18 +1813,12 @@
           <a:p>
             <a:fld id="{C1FF6DA9-008F-8B48-92A6-B652298478BF}" type="slidenum">
               <a:rPr lang="en-US" smtClean="0"/>
-              <a:t>‹#›</a:t>
             </a:fld>
             <a:endParaRPr lang="en-US"/>
           </a:p>
         </p:txBody>
       </p:sp>
     </p:spTree>
-    <p:extLst>
-      <p:ext uri="{BB962C8B-B14F-4D97-AF65-F5344CB8AC3E}">
-        <p14:creationId xmlns:p14="http://schemas.microsoft.com/office/powerpoint/2010/main" val="990158736"/>
-      </p:ext>
-    </p:extLst>
   </p:cSld>
   <p:clrMapOvr>
     <a:masterClrMapping/>
@@ -1885,7 +1883,6 @@
           <a:p>
             <a:fld id="{5BCAD085-E8A6-8845-BD4E-CB4CCA059FC4}" type="datetimeFigureOut">
               <a:rPr lang="en-US" smtClean="0"/>
-              <a:t>1/27/13</a:t>
             </a:fld>
             <a:endParaRPr lang="en-US"/>
           </a:p>
@@ -1927,18 +1924,12 @@
           <a:p>
             <a:fld id="{C1FF6DA9-008F-8B48-92A6-B652298478BF}" type="slidenum">
               <a:rPr lang="en-US" smtClean="0"/>
-              <a:t>‹#›</a:t>
             </a:fld>
             <a:endParaRPr lang="en-US"/>
           </a:p>
         </p:txBody>
       </p:sp>
     </p:spTree>
-    <p:extLst>
-      <p:ext uri="{BB962C8B-B14F-4D97-AF65-F5344CB8AC3E}">
-        <p14:creationId xmlns:p14="http://schemas.microsoft.com/office/powerpoint/2010/main" val="727027711"/>
-      </p:ext>
-    </p:extLst>
   </p:cSld>
   <p:clrMapOvr>
     <a:masterClrMapping/>
@@ -1980,7 +1971,6 @@
           <a:p>
             <a:fld id="{5BCAD085-E8A6-8845-BD4E-CB4CCA059FC4}" type="datetimeFigureOut">
               <a:rPr lang="en-US" smtClean="0"/>
-              <a:t>1/27/13</a:t>
             </a:fld>
             <a:endParaRPr lang="en-US"/>
           </a:p>
@@ -2022,18 +2012,12 @@
           <a:p>
             <a:fld id="{C1FF6DA9-008F-8B48-92A6-B652298478BF}" type="slidenum">
               <a:rPr lang="en-US" smtClean="0"/>
-              <a:t>‹#›</a:t>
             </a:fld>
             <a:endParaRPr lang="en-US"/>
           </a:p>
         </p:txBody>
       </p:sp>
     </p:spTree>
-    <p:extLst>
-      <p:ext uri="{BB962C8B-B14F-4D97-AF65-F5344CB8AC3E}">
-        <p14:creationId xmlns:p14="http://schemas.microsoft.com/office/powerpoint/2010/main" val="1212999818"/>
-      </p:ext>
-    </p:extLst>
   </p:cSld>
   <p:clrMapOvr>
     <a:masterClrMapping/>
@@ -2143,6 +2127,7 @@
               <a:rPr lang="en-US" smtClean="0"/>
               <a:t>Click to edit Master text styles</a:t>
             </a:r>
+            <a:endParaRPr lang="en-US" smtClean="0"/>
           </a:p>
           <a:p>
             <a:pPr lvl="1"/>
@@ -2150,6 +2135,7 @@
               <a:rPr lang="en-US" smtClean="0"/>
               <a:t>Second level</a:t>
             </a:r>
+            <a:endParaRPr lang="en-US" smtClean="0"/>
           </a:p>
           <a:p>
             <a:pPr lvl="2"/>
@@ -2157,6 +2143,7 @@
               <a:rPr lang="en-US" smtClean="0"/>
               <a:t>Third level</a:t>
             </a:r>
+            <a:endParaRPr lang="en-US" smtClean="0"/>
           </a:p>
           <a:p>
             <a:pPr lvl="3"/>
@@ -2164,6 +2151,7 @@
               <a:rPr lang="en-US" smtClean="0"/>
               <a:t>Fourth level</a:t>
             </a:r>
+            <a:endParaRPr lang="en-US" smtClean="0"/>
           </a:p>
           <a:p>
             <a:pPr lvl="4"/>
@@ -2237,6 +2225,7 @@
               <a:rPr lang="en-US" smtClean="0"/>
               <a:t>Click to edit Master text styles</a:t>
             </a:r>
+            <a:endParaRPr lang="en-US" smtClean="0"/>
           </a:p>
         </p:txBody>
       </p:sp>
@@ -2257,7 +2246,6 @@
           <a:p>
             <a:fld id="{5BCAD085-E8A6-8845-BD4E-CB4CCA059FC4}" type="datetimeFigureOut">
               <a:rPr lang="en-US" smtClean="0"/>
-              <a:t>1/27/13</a:t>
             </a:fld>
             <a:endParaRPr lang="en-US"/>
           </a:p>
@@ -2299,18 +2287,12 @@
           <a:p>
             <a:fld id="{C1FF6DA9-008F-8B48-92A6-B652298478BF}" type="slidenum">
               <a:rPr lang="en-US" smtClean="0"/>
-              <a:t>‹#›</a:t>
             </a:fld>
             <a:endParaRPr lang="en-US"/>
           </a:p>
         </p:txBody>
       </p:sp>
     </p:spTree>
-    <p:extLst>
-      <p:ext uri="{BB962C8B-B14F-4D97-AF65-F5344CB8AC3E}">
-        <p14:creationId xmlns:p14="http://schemas.microsoft.com/office/powerpoint/2010/main" val="1840726560"/>
-      </p:ext>
-    </p:extLst>
   </p:cSld>
   <p:clrMapOvr>
     <a:masterClrMapping/>
@@ -2490,6 +2472,7 @@
               <a:rPr lang="en-US" smtClean="0"/>
               <a:t>Click to edit Master text styles</a:t>
             </a:r>
+            <a:endParaRPr lang="en-US" smtClean="0"/>
           </a:p>
         </p:txBody>
       </p:sp>
@@ -2510,7 +2493,6 @@
           <a:p>
             <a:fld id="{5BCAD085-E8A6-8845-BD4E-CB4CCA059FC4}" type="datetimeFigureOut">
               <a:rPr lang="en-US" smtClean="0"/>
-              <a:t>1/27/13</a:t>
             </a:fld>
             <a:endParaRPr lang="en-US"/>
           </a:p>
@@ -2552,18 +2534,12 @@
           <a:p>
             <a:fld id="{C1FF6DA9-008F-8B48-92A6-B652298478BF}" type="slidenum">
               <a:rPr lang="en-US" smtClean="0"/>
-              <a:t>‹#›</a:t>
             </a:fld>
             <a:endParaRPr lang="en-US"/>
           </a:p>
         </p:txBody>
       </p:sp>
     </p:spTree>
-    <p:extLst>
-      <p:ext uri="{BB962C8B-B14F-4D97-AF65-F5344CB8AC3E}">
-        <p14:creationId xmlns:p14="http://schemas.microsoft.com/office/powerpoint/2010/main" val="3889236939"/>
-      </p:ext>
-    </p:extLst>
   </p:cSld>
   <p:clrMapOvr>
     <a:masterClrMapping/>
@@ -2656,6 +2632,7 @@
               <a:rPr lang="en-US" smtClean="0"/>
               <a:t>Click to edit Master text styles</a:t>
             </a:r>
+            <a:endParaRPr lang="en-US" smtClean="0"/>
           </a:p>
           <a:p>
             <a:pPr lvl="1"/>
@@ -2663,6 +2640,7 @@
               <a:rPr lang="en-US" smtClean="0"/>
               <a:t>Second level</a:t>
             </a:r>
+            <a:endParaRPr lang="en-US" smtClean="0"/>
           </a:p>
           <a:p>
             <a:pPr lvl="2"/>
@@ -2670,6 +2648,7 @@
               <a:rPr lang="en-US" smtClean="0"/>
               <a:t>Third level</a:t>
             </a:r>
+            <a:endParaRPr lang="en-US" smtClean="0"/>
           </a:p>
           <a:p>
             <a:pPr lvl="3"/>
@@ -2677,6 +2656,7 @@
               <a:rPr lang="en-US" smtClean="0"/>
               <a:t>Fourth level</a:t>
             </a:r>
+            <a:endParaRPr lang="en-US" smtClean="0"/>
           </a:p>
           <a:p>
             <a:pPr lvl="4"/>
@@ -2723,7 +2703,6 @@
           <a:p>
             <a:fld id="{5BCAD085-E8A6-8845-BD4E-CB4CCA059FC4}" type="datetimeFigureOut">
               <a:rPr lang="en-US" smtClean="0"/>
-              <a:t>1/27/13</a:t>
             </a:fld>
             <a:endParaRPr lang="en-US"/>
           </a:p>
@@ -2801,18 +2780,12 @@
           <a:p>
             <a:fld id="{C1FF6DA9-008F-8B48-92A6-B652298478BF}" type="slidenum">
               <a:rPr lang="en-US" smtClean="0"/>
-              <a:t>‹#›</a:t>
             </a:fld>
             <a:endParaRPr lang="en-US"/>
           </a:p>
         </p:txBody>
       </p:sp>
     </p:spTree>
-    <p:extLst>
-      <p:ext uri="{BB962C8B-B14F-4D97-AF65-F5344CB8AC3E}">
-        <p14:creationId xmlns:p14="http://schemas.microsoft.com/office/powerpoint/2010/main" val="2209977519"/>
-      </p:ext>
-    </p:extLst>
   </p:cSld>
   <p:clrMap bg1="lt1" tx1="dk1" bg2="lt2" tx2="dk2" accent1="accent1" accent2="accent2" accent3="accent3" accent4="accent4" accent5="accent5" accent6="accent6" hlink="hlink" folHlink="folHlink"/>
   <p:sldLayoutIdLst>
@@ -2850,7 +2823,7 @@
         <a:spcBef>
           <a:spcPct val="20000"/>
         </a:spcBef>
-        <a:buFont typeface="Arial"/>
+        <a:buFont typeface="Arial" panose="020B0604020202020204"/>
         <a:buChar char="•"/>
         <a:defRPr sz="3200" kern="1200">
           <a:solidFill>
@@ -2865,7 +2838,7 @@
         <a:spcBef>
           <a:spcPct val="20000"/>
         </a:spcBef>
-        <a:buFont typeface="Arial"/>
+        <a:buFont typeface="Arial" panose="020B0604020202020204"/>
         <a:buChar char="–"/>
         <a:defRPr sz="2800" kern="1200">
           <a:solidFill>
@@ -2880,7 +2853,7 @@
         <a:spcBef>
           <a:spcPct val="20000"/>
         </a:spcBef>
-        <a:buFont typeface="Arial"/>
+        <a:buFont typeface="Arial" panose="020B0604020202020204"/>
         <a:buChar char="•"/>
         <a:defRPr sz="2400" kern="1200">
           <a:solidFill>
@@ -2895,7 +2868,7 @@
         <a:spcBef>
           <a:spcPct val="20000"/>
         </a:spcBef>
-        <a:buFont typeface="Arial"/>
+        <a:buFont typeface="Arial" panose="020B0604020202020204"/>
         <a:buChar char="–"/>
         <a:defRPr sz="2000" kern="1200">
           <a:solidFill>
@@ -2910,7 +2883,7 @@
         <a:spcBef>
           <a:spcPct val="20000"/>
         </a:spcBef>
-        <a:buFont typeface="Arial"/>
+        <a:buFont typeface="Arial" panose="020B0604020202020204"/>
         <a:buChar char="»"/>
         <a:defRPr sz="2000" kern="1200">
           <a:solidFill>
@@ -2925,7 +2898,7 @@
         <a:spcBef>
           <a:spcPct val="20000"/>
         </a:spcBef>
-        <a:buFont typeface="Arial"/>
+        <a:buFont typeface="Arial" panose="020B0604020202020204"/>
         <a:buChar char="•"/>
         <a:defRPr sz="2000" kern="1200">
           <a:solidFill>
@@ -2940,7 +2913,7 @@
         <a:spcBef>
           <a:spcPct val="20000"/>
         </a:spcBef>
-        <a:buFont typeface="Arial"/>
+        <a:buFont typeface="Arial" panose="020B0604020202020204"/>
         <a:buChar char="•"/>
         <a:defRPr sz="2000" kern="1200">
           <a:solidFill>
@@ -2955,7 +2928,7 @@
         <a:spcBef>
           <a:spcPct val="20000"/>
         </a:spcBef>
-        <a:buFont typeface="Arial"/>
+        <a:buFont typeface="Arial" panose="020B0604020202020204"/>
         <a:buChar char="•"/>
         <a:defRPr sz="2000" kern="1200">
           <a:solidFill>
@@ -2970,7 +2943,7 @@
         <a:spcBef>
           <a:spcPct val="20000"/>
         </a:spcBef>
-        <a:buFont typeface="Arial"/>
+        <a:buFont typeface="Arial" panose="020B0604020202020204"/>
         <a:buChar char="•"/>
         <a:defRPr sz="2000" kern="1200">
           <a:solidFill>
@@ -3082,7 +3055,7 @@
 </file>
 
 <file path=ppt/slides/slide1.xml><?xml version="1.0" encoding="utf-8"?>
-<p:sld xmlns:a="http://schemas.openxmlformats.org/drawingml/2006/main" xmlns:p="http://schemas.openxmlformats.org/presentationml/2006/main" xmlns:r="http://schemas.openxmlformats.org/officeDocument/2006/relationships">
+<p:sld xmlns:a="http://schemas.openxmlformats.org/drawingml/2006/main" xmlns:r="http://schemas.openxmlformats.org/officeDocument/2006/relationships" xmlns:p="http://schemas.openxmlformats.org/presentationml/2006/main">
   <p:cSld>
     <p:spTree>
       <p:nvGrpSpPr>
@@ -3204,6 +3177,9 @@
               <a:rPr/>
               <a:t>论文标题</a:t>
             </a:r>
+            <a:endParaRPr sz="3800" b="1">
+              <a:latin typeface="Arial" panose="020B0604020202020204"/>
+            </a:endParaRPr>
           </a:p>
         </p:txBody>
       </p:sp>
@@ -3274,14 +3250,26 @@
           <a:p>
             <a:pPr algn="l"/>
             <a:r>
-              <a:rPr sz="1600" b="0">
-                <a:solidFill>
-                  <a:srgbClr val="888888"/>
-                </a:solidFill>
-                <a:latin typeface="Arial"/>
+              <a:rPr sz="2000" b="1">
+                <a:latin typeface="Times New Roman"/>
+              </a:rPr>
+              <a:t>汇报人：</a:t>
+            </a:r>
+            <a:r>
+              <a:rPr sz="2000" b="1">
+                <a:latin typeface="微软雅黑"/>
               </a:rPr>
               <a:t>xxx</a:t>
             </a:r>
+            <a:r>
+              <a:rPr sz="1600">
+                <a:latin typeface="Times New Roman"/>
+              </a:rPr>
+              <a:t>xxx</a:t>
+            </a:r>
+            <a:endParaRPr sz="1600">
+              <a:latin typeface="Times New Roman" panose="02020603050405020304"/>
+            </a:endParaRPr>
           </a:p>
         </p:txBody>
       </p:sp>
@@ -3460,6 +3448,278 @@
       <p:sp>
         <p:nvSpPr>
           <p:cNvPr id="11" name="Rectangle 10"/>
+          <p:cNvSpPr/>
+          <p:nvPr/>
+        </p:nvSpPr>
+        <p:spPr>
+          <a:xfrm>
+            <a:off x="0" y="6400800"/>
+            <a:ext cx="12188952" cy="73152"/>
+          </a:xfrm>
+          <a:prstGeom prst="rect">
+            <a:avLst/>
+          </a:prstGeom>
+          <a:solidFill>
+            <a:srgbClr val="E63946"/>
+          </a:solidFill>
+          <a:ln>
+            <a:noFill/>
+          </a:ln>
+        </p:spPr>
+        <p:style>
+          <a:lnRef idx="1">
+            <a:schemeClr val="accent1"/>
+          </a:lnRef>
+          <a:fillRef idx="3">
+            <a:schemeClr val="accent1"/>
+          </a:fillRef>
+          <a:effectRef idx="2">
+            <a:schemeClr val="accent1"/>
+          </a:effectRef>
+          <a:fontRef idx="minor">
+            <a:schemeClr val="lt1"/>
+          </a:fontRef>
+        </p:style>
+        <p:txBody>
+          <a:bodyPr rtlCol="0" anchor="ctr"/>
+          <a:lstStyle/>
+          <a:p>
+            <a:pPr algn="ctr"/>
+          </a:p>
+        </p:txBody>
+      </p:sp>
+    </p:spTree>
+  </p:cSld>
+  <p:clrMapOvr>
+    <a:masterClrMapping/>
+  </p:clrMapOvr>
+</p:sld>
+</file>
+
+<file path=ppt/slides/slide17.xml><?xml version="1.0" encoding="utf-8"?>
+<p:sld xmlns:a="http://schemas.openxmlformats.org/drawingml/2006/main" xmlns:r="http://schemas.openxmlformats.org/officeDocument/2006/relationships" xmlns:p="http://schemas.openxmlformats.org/presentationml/2006/main">
+  <p:cSld>
+    <p:spTree>
+      <p:nvGrpSpPr>
+        <p:cNvPr id="1" name=""/>
+        <p:cNvGrpSpPr/>
+        <p:nvPr/>
+      </p:nvGrpSpPr>
+      <p:grpSpPr/>
+      <p:sp>
+        <p:nvSpPr>
+          <p:cNvPr id="2" name="Rectangle 1"/>
+          <p:cNvSpPr/>
+          <p:nvPr/>
+        </p:nvSpPr>
+        <p:spPr>
+          <a:xfrm>
+            <a:off x="0" y="0"/>
+            <a:ext cx="12188952" cy="6858000"/>
+          </a:xfrm>
+          <a:prstGeom prst="rect">
+            <a:avLst/>
+          </a:prstGeom>
+          <a:solidFill>
+            <a:srgbClr val="1A1A1A"/>
+          </a:solidFill>
+          <a:ln>
+            <a:noFill/>
+          </a:ln>
+        </p:spPr>
+        <p:style>
+          <a:lnRef idx="1">
+            <a:schemeClr val="accent1"/>
+          </a:lnRef>
+          <a:fillRef idx="3">
+            <a:schemeClr val="accent1"/>
+          </a:fillRef>
+          <a:effectRef idx="2">
+            <a:schemeClr val="accent1"/>
+          </a:effectRef>
+          <a:fontRef idx="minor">
+            <a:schemeClr val="lt1"/>
+          </a:fontRef>
+        </p:style>
+        <p:txBody>
+          <a:bodyPr rtlCol="0" anchor="ctr"/>
+          <a:lstStyle/>
+          <a:p>
+            <a:pPr algn="ctr"/>
+          </a:p>
+        </p:txBody>
+      </p:sp>
+      <p:sp>
+        <p:nvSpPr>
+          <p:cNvPr id="3" name="Rectangle 2"/>
+          <p:cNvSpPr/>
+          <p:nvPr/>
+        </p:nvSpPr>
+        <p:spPr>
+          <a:xfrm>
+            <a:off x="0" y="0"/>
+            <a:ext cx="1097280" cy="6858000"/>
+          </a:xfrm>
+          <a:prstGeom prst="rect">
+            <a:avLst/>
+          </a:prstGeom>
+          <a:solidFill>
+            <a:srgbClr val="E63946"/>
+          </a:solidFill>
+          <a:ln>
+            <a:noFill/>
+          </a:ln>
+        </p:spPr>
+        <p:style>
+          <a:lnRef idx="1">
+            <a:schemeClr val="accent1"/>
+          </a:lnRef>
+          <a:fillRef idx="3">
+            <a:schemeClr val="accent1"/>
+          </a:fillRef>
+          <a:effectRef idx="2">
+            <a:schemeClr val="accent1"/>
+          </a:effectRef>
+          <a:fontRef idx="minor">
+            <a:schemeClr val="lt1"/>
+          </a:fontRef>
+        </p:style>
+        <p:txBody>
+          <a:bodyPr rtlCol="0" anchor="ctr"/>
+          <a:lstStyle/>
+          <a:p>
+            <a:pPr algn="ctr"/>
+          </a:p>
+        </p:txBody>
+      </p:sp>
+      <p:sp>
+        <p:nvSpPr>
+          <p:cNvPr id="4" name="TextBox 3"/>
+          <p:cNvSpPr txBox="1"/>
+          <p:nvPr/>
+        </p:nvSpPr>
+        <p:spPr>
+          <a:xfrm>
+            <a:off x="1828800" y="2286000"/>
+            <a:ext cx="9144000" cy="1371600"/>
+          </a:xfrm>
+          <a:prstGeom prst="rect">
+            <a:avLst/>
+          </a:prstGeom>
+          <a:noFill/>
+        </p:spPr>
+        <p:txBody>
+          <a:bodyPr wrap="square">
+            <a:spAutoFit/>
+          </a:bodyPr>
+          <a:lstStyle/>
+          <a:p>
+            <a:pPr algn="l"/>
+            <a:r>
+              <a:rPr sz="7200" b="1">
+                <a:solidFill>
+                  <a:srgbClr val="FFFFFF"/>
+                </a:solidFill>
+                <a:latin typeface="Arial" panose="020B0604020202020204"/>
+              </a:rPr>
+              <a:t>THANKS</a:t>
+            </a:r>
+            <a:endParaRPr sz="7200" b="1">
+              <a:solidFill>
+                <a:srgbClr val="FFFFFF"/>
+              </a:solidFill>
+              <a:latin typeface="Arial" panose="020B0604020202020204"/>
+            </a:endParaRPr>
+          </a:p>
+        </p:txBody>
+      </p:sp>
+      <p:sp>
+        <p:nvSpPr>
+          <p:cNvPr id="5" name="Rectangle 4"/>
+          <p:cNvSpPr/>
+          <p:nvPr/>
+        </p:nvSpPr>
+        <p:spPr>
+          <a:xfrm>
+            <a:off x="1828800" y="3749039"/>
+            <a:ext cx="2743200" cy="54864"/>
+          </a:xfrm>
+          <a:prstGeom prst="rect">
+            <a:avLst/>
+          </a:prstGeom>
+          <a:solidFill>
+            <a:srgbClr val="E63946"/>
+          </a:solidFill>
+          <a:ln>
+            <a:noFill/>
+          </a:ln>
+        </p:spPr>
+        <p:style>
+          <a:lnRef idx="1">
+            <a:schemeClr val="accent1"/>
+          </a:lnRef>
+          <a:fillRef idx="3">
+            <a:schemeClr val="accent1"/>
+          </a:fillRef>
+          <a:effectRef idx="2">
+            <a:schemeClr val="accent1"/>
+          </a:effectRef>
+          <a:fontRef idx="minor">
+            <a:schemeClr val="lt1"/>
+          </a:fontRef>
+        </p:style>
+        <p:txBody>
+          <a:bodyPr rtlCol="0" anchor="ctr"/>
+          <a:lstStyle/>
+          <a:p>
+            <a:pPr algn="ctr"/>
+          </a:p>
+        </p:txBody>
+      </p:sp>
+      <p:sp>
+        <p:nvSpPr>
+          <p:cNvPr id="6" name="TextBox 5"/>
+          <p:cNvSpPr txBox="1"/>
+          <p:nvPr/>
+        </p:nvSpPr>
+        <p:spPr>
+          <a:xfrm>
+            <a:off x="1828800" y="4114800"/>
+            <a:ext cx="4572000" cy="457200"/>
+          </a:xfrm>
+          <a:prstGeom prst="rect">
+            <a:avLst/>
+          </a:prstGeom>
+          <a:noFill/>
+        </p:spPr>
+        <p:txBody>
+          <a:bodyPr wrap="square">
+            <a:spAutoFit/>
+          </a:bodyPr>
+          <a:lstStyle/>
+          <a:p>
+            <a:pPr algn="l"/>
+            <a:r>
+              <a:rPr sz="2400" b="0">
+                <a:solidFill>
+                  <a:srgbClr val="FFFFFF"/>
+                </a:solidFill>
+                <a:latin typeface="Arial" panose="020B0604020202020204"/>
+              </a:rPr>
+              <a:t>Thank You</a:t>
+            </a:r>
+            <a:endParaRPr sz="2400" b="0">
+              <a:solidFill>
+                <a:srgbClr val="FFFFFF"/>
+              </a:solidFill>
+              <a:latin typeface="Arial" panose="020B0604020202020204"/>
+            </a:endParaRPr>
+          </a:p>
+        </p:txBody>
+      </p:sp>
+      <p:sp>
+        <p:nvSpPr>
+          <p:cNvPr id="7" name="Rectangle 6"/>
           <p:cNvSpPr/>
           <p:nvPr/>
         </p:nvSpPr>
@@ -3509,7 +3769,7 @@
 </file>
 
 <file path=ppt/slides/slide2.xml><?xml version="1.0" encoding="utf-8"?>
-<p:sld xmlns:a="http://schemas.openxmlformats.org/drawingml/2006/main" xmlns:p="http://schemas.openxmlformats.org/presentationml/2006/main" xmlns:r="http://schemas.openxmlformats.org/officeDocument/2006/relationships">
+<p:sld xmlns:a="http://schemas.openxmlformats.org/drawingml/2006/main" xmlns:r="http://schemas.openxmlformats.org/officeDocument/2006/relationships" xmlns:p="http://schemas.openxmlformats.org/presentationml/2006/main">
   <p:cSld>
     <p:spTree>
       <p:nvGrpSpPr>
@@ -3632,10 +3892,16 @@
                 <a:solidFill>
                   <a:srgbClr val="1A1A1A"/>
                 </a:solidFill>
-                <a:latin typeface="Arial"/>
+                <a:latin typeface="Arial" panose="020B0604020202020204"/>
               </a:rPr>
               <a:t>CONTENTS</a:t>
             </a:r>
+            <a:endParaRPr sz="3000" b="1">
+              <a:solidFill>
+                <a:srgbClr val="1A1A1A"/>
+              </a:solidFill>
+              <a:latin typeface="Arial" panose="020B0604020202020204"/>
+            </a:endParaRPr>
           </a:p>
         </p:txBody>
       </p:sp>
@@ -3710,10 +3976,16 @@
                 <a:solidFill>
                   <a:srgbClr val="E63946"/>
                 </a:solidFill>
-                <a:latin typeface="Arial"/>
+                <a:latin typeface="Arial" panose="020B0604020202020204"/>
               </a:rPr>
               <a:t>01</a:t>
             </a:r>
+            <a:endParaRPr sz="2000" b="1">
+              <a:solidFill>
+                <a:srgbClr val="E63946"/>
+              </a:solidFill>
+              <a:latin typeface="Arial" panose="020B0604020202020204"/>
+            </a:endParaRPr>
           </a:p>
         </p:txBody>
       </p:sp>
@@ -3745,10 +4017,16 @@
                 <a:solidFill>
                   <a:srgbClr val="1A1A1A"/>
                 </a:solidFill>
-                <a:latin typeface="Arial"/>
+                <a:latin typeface="Arial" panose="020B0604020202020204"/>
               </a:rPr>
               <a:t>章节名称</a:t>
             </a:r>
+            <a:endParaRPr sz="2200" b="0">
+              <a:solidFill>
+                <a:srgbClr val="1A1A1A"/>
+              </a:solidFill>
+              <a:latin typeface="Arial" panose="020B0604020202020204"/>
+            </a:endParaRPr>
           </a:p>
         </p:txBody>
       </p:sp>
@@ -3803,7 +4081,7 @@
         </p:nvSpPr>
         <p:spPr>
           <a:xfrm>
-            <a:off x="1371600" y="2834640"/>
+            <a:off x="1371600" y="2583180"/>
             <a:ext cx="731520" cy="457200"/>
           </a:xfrm>
           <a:prstGeom prst="rect">
@@ -3823,10 +4101,16 @@
                 <a:solidFill>
                   <a:srgbClr val="E63946"/>
                 </a:solidFill>
-                <a:latin typeface="Arial"/>
+                <a:latin typeface="Arial" panose="020B0604020202020204"/>
               </a:rPr>
-              <a:t>02</a:t>
-            </a:r>
+              <a:t/>
+            </a:r>
+            <a:endParaRPr sz="2000" b="1">
+              <a:solidFill>
+                <a:srgbClr val="E63946"/>
+              </a:solidFill>
+              <a:latin typeface="Arial" panose="020B0604020202020204"/>
+            </a:endParaRPr>
           </a:p>
         </p:txBody>
       </p:sp>
@@ -3838,7 +4122,7 @@
         </p:nvSpPr>
         <p:spPr>
           <a:xfrm>
-            <a:off x="2286000" y="2834640"/>
+            <a:off x="2286000" y="2583180"/>
             <a:ext cx="7315200" cy="457200"/>
           </a:xfrm>
           <a:prstGeom prst="rect">
@@ -3858,10 +4142,16 @@
                 <a:solidFill>
                   <a:srgbClr val="1A1A1A"/>
                 </a:solidFill>
-                <a:latin typeface="Arial"/>
+                <a:latin typeface="Arial" panose="020B0604020202020204"/>
               </a:rPr>
-              <a:t>章节名称</a:t>
-            </a:r>
+              <a:t/>
+            </a:r>
+            <a:endParaRPr sz="2200" b="0">
+              <a:solidFill>
+                <a:srgbClr val="1A1A1A"/>
+              </a:solidFill>
+              <a:latin typeface="Arial" panose="020B0604020202020204"/>
+            </a:endParaRPr>
           </a:p>
         </p:txBody>
       </p:sp>
@@ -3873,7 +4163,7 @@
         </p:nvSpPr>
         <p:spPr>
           <a:xfrm>
-            <a:off x="2286000" y="3337560"/>
+            <a:off x="2286000" y="3840480"/>
             <a:ext cx="8229600" cy="18288"/>
           </a:xfrm>
           <a:prstGeom prst="rect">
@@ -3916,7 +4206,7 @@
         </p:nvSpPr>
         <p:spPr>
           <a:xfrm>
-            <a:off x="1371600" y="3840480"/>
+            <a:off x="1371600" y="3337560"/>
             <a:ext cx="731520" cy="457200"/>
           </a:xfrm>
           <a:prstGeom prst="rect">
@@ -3936,10 +4226,16 @@
                 <a:solidFill>
                   <a:srgbClr val="E63946"/>
                 </a:solidFill>
-                <a:latin typeface="Arial"/>
+                <a:latin typeface="Arial" panose="020B0604020202020204"/>
               </a:rPr>
-              <a:t>03</a:t>
-            </a:r>
+              <a:t/>
+            </a:r>
+            <a:endParaRPr sz="2000" b="1">
+              <a:solidFill>
+                <a:srgbClr val="E63946"/>
+              </a:solidFill>
+              <a:latin typeface="Arial" panose="020B0604020202020204"/>
+            </a:endParaRPr>
           </a:p>
         </p:txBody>
       </p:sp>
@@ -3951,7 +4247,7 @@
         </p:nvSpPr>
         <p:spPr>
           <a:xfrm>
-            <a:off x="2286000" y="3840480"/>
+            <a:off x="2286000" y="3337560"/>
             <a:ext cx="7315200" cy="457200"/>
           </a:xfrm>
           <a:prstGeom prst="rect">
@@ -3971,10 +4267,16 @@
                 <a:solidFill>
                   <a:srgbClr val="1A1A1A"/>
                 </a:solidFill>
-                <a:latin typeface="Arial"/>
+                <a:latin typeface="Arial" panose="020B0604020202020204"/>
               </a:rPr>
-              <a:t>章节名称</a:t>
-            </a:r>
+              <a:t/>
+            </a:r>
+            <a:endParaRPr sz="2200" b="0">
+              <a:solidFill>
+                <a:srgbClr val="1A1A1A"/>
+              </a:solidFill>
+              <a:latin typeface="Arial" panose="020B0604020202020204"/>
+            </a:endParaRPr>
           </a:p>
         </p:txBody>
       </p:sp>
@@ -3986,7 +4288,7 @@
         </p:nvSpPr>
         <p:spPr>
           <a:xfrm>
-            <a:off x="2286000" y="4343400"/>
+            <a:off x="2286000" y="4594860"/>
             <a:ext cx="8229600" cy="18288"/>
           </a:xfrm>
           <a:prstGeom prst="rect">
@@ -4029,7 +4331,7 @@
         </p:nvSpPr>
         <p:spPr>
           <a:xfrm>
-            <a:off x="1371600" y="4846320"/>
+            <a:off x="1371600" y="4091940"/>
             <a:ext cx="731520" cy="457200"/>
           </a:xfrm>
           <a:prstGeom prst="rect">
@@ -4049,10 +4351,16 @@
                 <a:solidFill>
                   <a:srgbClr val="E63946"/>
                 </a:solidFill>
-                <a:latin typeface="Arial"/>
+                <a:latin typeface="Arial" panose="020B0604020202020204"/>
               </a:rPr>
-              <a:t>04</a:t>
-            </a:r>
+              <a:t/>
+            </a:r>
+            <a:endParaRPr sz="2000" b="1">
+              <a:solidFill>
+                <a:srgbClr val="E63946"/>
+              </a:solidFill>
+              <a:latin typeface="Arial" panose="020B0604020202020204"/>
+            </a:endParaRPr>
           </a:p>
         </p:txBody>
       </p:sp>
@@ -4064,7 +4372,7 @@
         </p:nvSpPr>
         <p:spPr>
           <a:xfrm>
-            <a:off x="2286000" y="4846320"/>
+            <a:off x="2286000" y="4091940"/>
             <a:ext cx="7315200" cy="457200"/>
           </a:xfrm>
           <a:prstGeom prst="rect">
@@ -4084,10 +4392,16 @@
                 <a:solidFill>
                   <a:srgbClr val="1A1A1A"/>
                 </a:solidFill>
-                <a:latin typeface="Arial"/>
+                <a:latin typeface="Arial" panose="020B0604020202020204"/>
               </a:rPr>
-              <a:t>章节名称</a:t>
-            </a:r>
+              <a:t/>
+            </a:r>
+            <a:endParaRPr sz="2200" b="0">
+              <a:solidFill>
+                <a:srgbClr val="1A1A1A"/>
+              </a:solidFill>
+              <a:latin typeface="Arial" panose="020B0604020202020204"/>
+            </a:endParaRPr>
           </a:p>
         </p:txBody>
       </p:sp>
@@ -4150,6 +4464,131 @@
           </a:prstGeom>
           <a:solidFill>
             <a:srgbClr val="E63946"/>
+          </a:solidFill>
+          <a:ln>
+            <a:noFill/>
+          </a:ln>
+        </p:spPr>
+        <p:style>
+          <a:lnRef idx="1">
+            <a:schemeClr val="accent1"/>
+          </a:lnRef>
+          <a:fillRef idx="3">
+            <a:schemeClr val="accent1"/>
+          </a:fillRef>
+          <a:effectRef idx="2">
+            <a:schemeClr val="accent1"/>
+          </a:effectRef>
+          <a:fontRef idx="minor">
+            <a:schemeClr val="lt1"/>
+          </a:fontRef>
+        </p:style>
+        <p:txBody>
+          <a:bodyPr rtlCol="0" anchor="ctr"/>
+          <a:lstStyle/>
+          <a:p>
+            <a:pPr algn="ctr"/>
+          </a:p>
+        </p:txBody>
+      </p:sp>
+      <p:sp>
+        <p:nvSpPr>
+          <p:cNvPr id="19" name="TextBox 14"/>
+          <p:cNvSpPr txBox="1"/>
+          <p:nvPr/>
+        </p:nvSpPr>
+        <p:spPr>
+          <a:xfrm>
+            <a:off x="1371600" y="4846320"/>
+            <a:ext cx="731520" cy="457200"/>
+          </a:xfrm>
+          <a:prstGeom prst="rect">
+            <a:avLst/>
+          </a:prstGeom>
+          <a:noFill/>
+        </p:spPr>
+        <p:txBody>
+          <a:bodyPr wrap="square">
+            <a:spAutoFit/>
+          </a:bodyPr>
+          <a:lstStyle/>
+          <a:p>
+            <a:pPr algn="l"/>
+            <a:r>
+              <a:rPr sz="2000" b="1">
+                <a:solidFill>
+                  <a:srgbClr val="E63946"/>
+                </a:solidFill>
+                <a:latin typeface="Arial" panose="020B0604020202020204"/>
+              </a:rPr>
+              <a:t/>
+            </a:r>
+            <a:endParaRPr sz="2000" b="1">
+              <a:solidFill>
+                <a:srgbClr val="E63946"/>
+              </a:solidFill>
+              <a:latin typeface="Arial" panose="020B0604020202020204"/>
+            </a:endParaRPr>
+          </a:p>
+        </p:txBody>
+      </p:sp>
+      <p:sp>
+        <p:nvSpPr>
+          <p:cNvPr id="20" name="TextBox 15"/>
+          <p:cNvSpPr txBox="1"/>
+          <p:nvPr/>
+        </p:nvSpPr>
+        <p:spPr>
+          <a:xfrm>
+            <a:off x="2286000" y="4846320"/>
+            <a:ext cx="7315200" cy="457200"/>
+          </a:xfrm>
+          <a:prstGeom prst="rect">
+            <a:avLst/>
+          </a:prstGeom>
+          <a:noFill/>
+        </p:spPr>
+        <p:txBody>
+          <a:bodyPr wrap="square">
+            <a:spAutoFit/>
+          </a:bodyPr>
+          <a:lstStyle/>
+          <a:p>
+            <a:pPr algn="l"/>
+            <a:r>
+              <a:rPr sz="2200" b="0">
+                <a:solidFill>
+                  <a:srgbClr val="1A1A1A"/>
+                </a:solidFill>
+                <a:latin typeface="Arial" panose="020B0604020202020204"/>
+              </a:rPr>
+              <a:t/>
+            </a:r>
+            <a:endParaRPr sz="2200" b="0">
+              <a:solidFill>
+                <a:srgbClr val="1A1A1A"/>
+              </a:solidFill>
+              <a:latin typeface="Arial" panose="020B0604020202020204"/>
+            </a:endParaRPr>
+          </a:p>
+        </p:txBody>
+      </p:sp>
+      <p:sp>
+        <p:nvSpPr>
+          <p:cNvPr id="21" name="Rectangle 7"/>
+          <p:cNvSpPr/>
+          <p:nvPr/>
+        </p:nvSpPr>
+        <p:spPr>
+          <a:xfrm>
+            <a:off x="2286000" y="3086100"/>
+            <a:ext cx="8229600" cy="18288"/>
+          </a:xfrm>
+          <a:prstGeom prst="rect">
+            <a:avLst/>
+          </a:prstGeom>
+          <a:solidFill>
+            <a:srgbClr val="F2F2F2"/>
           </a:solidFill>
           <a:ln>
             <a:noFill/>
@@ -4186,7 +4625,7 @@
 </file>
 
 <file path=ppt/slides/slide3.xml><?xml version="1.0" encoding="utf-8"?>
-<p:sld xmlns:a="http://schemas.openxmlformats.org/drawingml/2006/main" xmlns:p="http://schemas.openxmlformats.org/presentationml/2006/main" xmlns:r="http://schemas.openxmlformats.org/officeDocument/2006/relationships">
+<p:sld xmlns:a="http://schemas.openxmlformats.org/drawingml/2006/main" xmlns:r="http://schemas.openxmlformats.org/officeDocument/2006/relationships" xmlns:p="http://schemas.openxmlformats.org/presentationml/2006/main">
   <p:cSld>
     <p:spTree>
       <p:nvGrpSpPr>
@@ -4309,10 +4748,16 @@
                 <a:solidFill>
                   <a:srgbClr val="FFFFFF"/>
                 </a:solidFill>
-                <a:latin typeface="Arial"/>
+                <a:latin typeface="Arial" panose="020B0604020202020204"/>
               </a:rPr>
               <a:t>01</a:t>
             </a:r>
+            <a:endParaRPr sz="5600" b="1">
+              <a:solidFill>
+                <a:srgbClr val="FFFFFF"/>
+              </a:solidFill>
+              <a:latin typeface="Arial" panose="020B0604020202020204"/>
+            </a:endParaRPr>
           </a:p>
         </p:txBody>
       </p:sp>
@@ -4340,8 +4785,20 @@
           <a:p>
             <a:pPr algn="l"/>
             <a:r>
+              <a:rPr sz="4400" b="1">
+                <a:solidFill>
+                  <a:srgbClr val="FFFFFF"/>
+                </a:solidFill>
+                <a:latin typeface="Arial" panose="020B0604020202020204"/>
+              </a:rPr>
               <a:t>章节标题</a:t>
             </a:r>
+            <a:endParaRPr sz="4400" b="1">
+              <a:solidFill>
+                <a:srgbClr val="FFFFFF"/>
+              </a:solidFill>
+              <a:latin typeface="Arial" panose="020B0604020202020204"/>
+            </a:endParaRPr>
           </a:p>
         </p:txBody>
       </p:sp>
@@ -4428,6 +4885,1788 @@
           <a:lstStyle/>
           <a:p>
             <a:pPr algn="ctr"/>
+          </a:p>
+        </p:txBody>
+      </p:sp>
+    </p:spTree>
+  </p:cSld>
+  <p:clrMapOvr>
+    <a:masterClrMapping/>
+  </p:clrMapOvr>
+</p:sld>
+</file>
+
+<file path=ppt/slides/slide4.xml><?xml version="1.0" encoding="utf-8"?>
+<p:sld xmlns:a="http://schemas.openxmlformats.org/drawingml/2006/main" xmlns:r="http://schemas.openxmlformats.org/officeDocument/2006/relationships" xmlns:p="http://schemas.openxmlformats.org/presentationml/2006/main">
+  <p:cSld>
+    <p:spTree>
+      <p:nvGrpSpPr>
+        <p:cNvPr id="1" name=""/>
+        <p:cNvGrpSpPr/>
+        <p:nvPr/>
+      </p:nvGrpSpPr>
+      <p:grpSpPr/>
+      <p:sp>
+        <p:nvSpPr>
+          <p:cNvPr id="2" name="Rectangle 1"/>
+          <p:cNvSpPr/>
+          <p:nvPr/>
+        </p:nvSpPr>
+        <p:spPr>
+          <a:xfrm>
+            <a:off x="0" y="0"/>
+            <a:ext cx="12188952" cy="6858000"/>
+          </a:xfrm>
+          <a:prstGeom prst="rect">
+            <a:avLst/>
+          </a:prstGeom>
+          <a:solidFill>
+            <a:srgbClr val="FFFFFF"/>
+          </a:solidFill>
+          <a:ln>
+            <a:noFill/>
+          </a:ln>
+        </p:spPr>
+        <p:style>
+          <a:lnRef idx="1">
+            <a:schemeClr val="accent1"/>
+          </a:lnRef>
+          <a:fillRef idx="3">
+            <a:schemeClr val="accent1"/>
+          </a:fillRef>
+          <a:effectRef idx="2">
+            <a:schemeClr val="accent1"/>
+          </a:effectRef>
+          <a:fontRef idx="minor">
+            <a:schemeClr val="lt1"/>
+          </a:fontRef>
+        </p:style>
+        <p:txBody>
+          <a:bodyPr rtlCol="0" anchor="ctr"/>
+          <a:lstStyle/>
+          <a:p>
+            <a:pPr algn="ctr"/>
+          </a:p>
+        </p:txBody>
+      </p:sp>
+      <p:sp>
+        <p:nvSpPr>
+          <p:cNvPr id="3" name="Rectangle 2"/>
+          <p:cNvSpPr/>
+          <p:nvPr/>
+        </p:nvSpPr>
+        <p:spPr>
+          <a:xfrm>
+            <a:off x="0" y="0"/>
+            <a:ext cx="12188952" cy="777240"/>
+          </a:xfrm>
+          <a:prstGeom prst="rect">
+            <a:avLst/>
+          </a:prstGeom>
+          <a:solidFill>
+            <a:srgbClr val="1A1A1A"/>
+          </a:solidFill>
+          <a:ln>
+            <a:noFill/>
+          </a:ln>
+        </p:spPr>
+        <p:style>
+          <a:lnRef idx="1">
+            <a:schemeClr val="accent1"/>
+          </a:lnRef>
+          <a:fillRef idx="3">
+            <a:schemeClr val="accent1"/>
+          </a:fillRef>
+          <a:effectRef idx="2">
+            <a:schemeClr val="accent1"/>
+          </a:effectRef>
+          <a:fontRef idx="minor">
+            <a:schemeClr val="lt1"/>
+          </a:fontRef>
+        </p:style>
+        <p:txBody>
+          <a:bodyPr rtlCol="0" anchor="ctr"/>
+          <a:lstStyle/>
+          <a:p>
+            <a:pPr algn="ctr"/>
+          </a:p>
+        </p:txBody>
+      </p:sp>
+      <p:sp>
+        <p:nvSpPr>
+          <p:cNvPr id="4" name="Rectangle 3"/>
+          <p:cNvSpPr/>
+          <p:nvPr/>
+        </p:nvSpPr>
+        <p:spPr>
+          <a:xfrm>
+            <a:off x="274320" y="201168"/>
+            <a:ext cx="109728" cy="384048"/>
+          </a:xfrm>
+          <a:prstGeom prst="rect">
+            <a:avLst/>
+          </a:prstGeom>
+          <a:solidFill>
+            <a:srgbClr val="E63946"/>
+          </a:solidFill>
+          <a:ln>
+            <a:noFill/>
+          </a:ln>
+        </p:spPr>
+        <p:style>
+          <a:lnRef idx="1">
+            <a:schemeClr val="accent1"/>
+          </a:lnRef>
+          <a:fillRef idx="3">
+            <a:schemeClr val="accent1"/>
+          </a:fillRef>
+          <a:effectRef idx="2">
+            <a:schemeClr val="accent1"/>
+          </a:effectRef>
+          <a:fontRef idx="minor">
+            <a:schemeClr val="lt1"/>
+          </a:fontRef>
+        </p:style>
+        <p:txBody>
+          <a:bodyPr rtlCol="0" anchor="ctr"/>
+          <a:lstStyle/>
+          <a:p>
+            <a:pPr algn="ctr"/>
+          </a:p>
+        </p:txBody>
+      </p:sp>
+      <p:sp>
+        <p:nvSpPr>
+          <p:cNvPr id="5" name="Rectangle 4"/>
+          <p:cNvSpPr/>
+          <p:nvPr/>
+        </p:nvSpPr>
+        <p:spPr>
+          <a:xfrm>
+            <a:off x="457200" y="640080"/>
+            <a:ext cx="11247120" cy="27432"/>
+          </a:xfrm>
+          <a:prstGeom prst="rect">
+            <a:avLst/>
+          </a:prstGeom>
+          <a:solidFill>
+            <a:srgbClr val="E63946"/>
+          </a:solidFill>
+          <a:ln>
+            <a:noFill/>
+          </a:ln>
+        </p:spPr>
+        <p:style>
+          <a:lnRef idx="1">
+            <a:schemeClr val="accent1"/>
+          </a:lnRef>
+          <a:fillRef idx="3">
+            <a:schemeClr val="accent1"/>
+          </a:fillRef>
+          <a:effectRef idx="2">
+            <a:schemeClr val="accent1"/>
+          </a:effectRef>
+          <a:fontRef idx="minor">
+            <a:schemeClr val="lt1"/>
+          </a:fontRef>
+        </p:style>
+        <p:txBody>
+          <a:bodyPr rtlCol="0" anchor="ctr"/>
+          <a:lstStyle/>
+          <a:p>
+            <a:pPr algn="ctr"/>
+          </a:p>
+        </p:txBody>
+      </p:sp>
+      <p:sp>
+        <p:nvSpPr>
+          <p:cNvPr id="6" name="TextBox 5"/>
+          <p:cNvSpPr txBox="1"/>
+          <p:nvPr/>
+        </p:nvSpPr>
+        <p:spPr>
+          <a:xfrm>
+            <a:off x="457200" y="137160"/>
+            <a:ext cx="11247120" cy="502920"/>
+          </a:xfrm>
+          <a:prstGeom prst="rect">
+            <a:avLst/>
+          </a:prstGeom>
+          <a:noFill/>
+        </p:spPr>
+        <p:txBody>
+          <a:bodyPr wrap="square">
+            <a:spAutoFit/>
+          </a:bodyPr>
+          <a:lstStyle/>
+          <a:p>
+            <a:pPr algn="l"/>
+            <a:r>
+              <a:rPr sz="2400" b="1">
+                <a:solidFill>
+                  <a:srgbClr val="E63946"/>
+                </a:solidFill>
+                <a:latin typeface="Arial" panose="020B0604020202020204"/>
+              </a:rPr>
+              <a:t>课题背景</a:t>
+            </a:r>
+            <a:endParaRPr sz="2400" b="1">
+              <a:solidFill>
+                <a:srgbClr val="E63946"/>
+              </a:solidFill>
+              <a:latin typeface="Arial" panose="020B0604020202020204"/>
+            </a:endParaRPr>
+          </a:p>
+        </p:txBody>
+      </p:sp>
+      <p:sp>
+        <p:nvSpPr>
+          <p:cNvPr id="7" name="Rectangle 6"/>
+          <p:cNvSpPr/>
+          <p:nvPr/>
+        </p:nvSpPr>
+        <p:spPr>
+          <a:xfrm>
+            <a:off x="0" y="6400800"/>
+            <a:ext cx="12188952" cy="54864"/>
+          </a:xfrm>
+          <a:prstGeom prst="rect">
+            <a:avLst/>
+          </a:prstGeom>
+          <a:solidFill>
+            <a:srgbClr val="E63946"/>
+          </a:solidFill>
+          <a:ln>
+            <a:noFill/>
+          </a:ln>
+        </p:spPr>
+        <p:style>
+          <a:lnRef idx="1">
+            <a:schemeClr val="accent1"/>
+          </a:lnRef>
+          <a:fillRef idx="3">
+            <a:schemeClr val="accent1"/>
+          </a:fillRef>
+          <a:effectRef idx="2">
+            <a:schemeClr val="accent1"/>
+          </a:effectRef>
+          <a:fontRef idx="minor">
+            <a:schemeClr val="lt1"/>
+          </a:fontRef>
+        </p:style>
+        <p:txBody>
+          <a:bodyPr rtlCol="0" anchor="ctr"/>
+          <a:lstStyle/>
+          <a:p>
+            <a:pPr algn="ctr"/>
+          </a:p>
+        </p:txBody>
+      </p:sp>
+      <p:sp>
+        <p:nvSpPr>
+          <p:cNvPr id="8" name="Rounded Rectangle 7"/>
+          <p:cNvSpPr/>
+          <p:nvPr/>
+        </p:nvSpPr>
+        <p:spPr>
+          <a:xfrm>
+            <a:off x="365760" y="1005840"/>
+            <a:ext cx="5303520" cy="2286000"/>
+          </a:xfrm>
+          <a:prstGeom prst="roundRect">
+            <a:avLst/>
+          </a:prstGeom>
+          <a:solidFill>
+            <a:srgbClr val="E0F0F5"/>
+          </a:solidFill>
+          <a:ln>
+            <a:noFill/>
+          </a:ln>
+        </p:spPr>
+        <p:style>
+          <a:lnRef idx="1">
+            <a:schemeClr val="accent1"/>
+          </a:lnRef>
+          <a:fillRef idx="3">
+            <a:schemeClr val="accent1"/>
+          </a:fillRef>
+          <a:effectRef idx="2">
+            <a:schemeClr val="accent1"/>
+          </a:effectRef>
+          <a:fontRef idx="minor">
+            <a:schemeClr val="lt1"/>
+          </a:fontRef>
+        </p:style>
+        <p:txBody>
+          <a:bodyPr rtlCol="0" anchor="ctr"/>
+          <a:lstStyle/>
+          <a:p>
+            <a:pPr algn="ctr"/>
+          </a:p>
+        </p:txBody>
+      </p:sp>
+      <p:sp>
+        <p:nvSpPr>
+          <p:cNvPr id="9" name="Rectangle 8"/>
+          <p:cNvSpPr/>
+          <p:nvPr/>
+        </p:nvSpPr>
+        <p:spPr>
+          <a:xfrm>
+            <a:off x="365760" y="1005840"/>
+            <a:ext cx="5303520" cy="457200"/>
+          </a:xfrm>
+          <a:prstGeom prst="rect">
+            <a:avLst/>
+          </a:prstGeom>
+          <a:solidFill>
+            <a:srgbClr val="007191"/>
+          </a:solidFill>
+          <a:ln>
+            <a:noFill/>
+          </a:ln>
+        </p:spPr>
+        <p:style>
+          <a:lnRef idx="1">
+            <a:schemeClr val="accent1"/>
+          </a:lnRef>
+          <a:fillRef idx="3">
+            <a:schemeClr val="accent1"/>
+          </a:fillRef>
+          <a:effectRef idx="2">
+            <a:schemeClr val="accent1"/>
+          </a:effectRef>
+          <a:fontRef idx="minor">
+            <a:schemeClr val="lt1"/>
+          </a:fontRef>
+        </p:style>
+        <p:txBody>
+          <a:bodyPr rtlCol="0" anchor="ctr"/>
+          <a:lstStyle/>
+          <a:p>
+            <a:pPr algn="ctr"/>
+          </a:p>
+        </p:txBody>
+      </p:sp>
+      <p:sp>
+        <p:nvSpPr>
+          <p:cNvPr id="10" name="TextBox 9"/>
+          <p:cNvSpPr txBox="1"/>
+          <p:nvPr/>
+        </p:nvSpPr>
+        <p:spPr>
+          <a:xfrm>
+            <a:off x="548640" y="1051560"/>
+            <a:ext cx="4937760" cy="365760"/>
+          </a:xfrm>
+          <a:prstGeom prst="rect">
+            <a:avLst/>
+          </a:prstGeom>
+          <a:noFill/>
+        </p:spPr>
+        <p:txBody>
+          <a:bodyPr wrap="square">
+            <a:spAutoFit/>
+          </a:bodyPr>
+          <a:lstStyle/>
+          <a:p>
+            <a:pPr algn="l"/>
+            <a:r>
+              <a:rPr sz="1800" b="1">
+                <a:solidFill>
+                  <a:srgbClr val="FFFFFF"/>
+                </a:solidFill>
+                <a:latin typeface="Arial" panose="020B0604020202020204"/>
+              </a:rPr>
+              <a:t>课题背景</a:t>
+            </a:r>
+            <a:endParaRPr sz="1800" b="1">
+              <a:solidFill>
+                <a:srgbClr val="FFFFFF"/>
+              </a:solidFill>
+              <a:latin typeface="Arial" panose="020B0604020202020204"/>
+            </a:endParaRPr>
+          </a:p>
+        </p:txBody>
+      </p:sp>
+      <p:sp>
+        <p:nvSpPr>
+          <p:cNvPr id="11" name="TextBox 10"/>
+          <p:cNvSpPr txBox="1"/>
+          <p:nvPr/>
+        </p:nvSpPr>
+        <p:spPr>
+          <a:xfrm>
+            <a:off x="640080" y="1645920"/>
+            <a:ext cx="4754880" cy="1371600"/>
+          </a:xfrm>
+          <a:prstGeom prst="rect">
+            <a:avLst/>
+          </a:prstGeom>
+          <a:noFill/>
+        </p:spPr>
+        <p:txBody>
+          <a:bodyPr wrap="square">
+            <a:spAutoFit/>
+          </a:bodyPr>
+          <a:lstStyle/>
+          <a:p>
+            <a:pPr>
+              <a:spcAft>
+                <a:spcPts val="200"/>
+              </a:spcAft>
+            </a:pPr>
+            <a:r>
+              <a:rPr sz="1600">
+                <a:solidFill>
+                  <a:srgbClr val="333333"/>
+                </a:solidFill>
+                <a:latin typeface="Arial" panose="020B0604020202020204"/>
+              </a:rPr>
+              <a:t>课题背景</a:t>
+            </a:r>
+            <a:endParaRPr sz="1600">
+              <a:solidFill>
+                <a:srgbClr val="333333"/>
+              </a:solidFill>
+              <a:latin typeface="Arial" panose="020B0604020202020204"/>
+            </a:endParaRPr>
+          </a:p>
+          <a:p>
+            <a:pPr>
+              <a:spcAft>
+                <a:spcPts val="200"/>
+              </a:spcAft>
+            </a:pPr>
+            <a:r>
+              <a:rPr sz="1600">
+                <a:solidFill>
+                  <a:srgbClr val="333333"/>
+                </a:solidFill>
+                <a:latin typeface="Arial" panose="020B0604020202020204"/>
+              </a:rPr>
+              <a:t> | </a:t>
+            </a:r>
+            <a:endParaRPr sz="1600">
+              <a:solidFill>
+                <a:srgbClr val="333333"/>
+              </a:solidFill>
+              <a:latin typeface="Arial" panose="020B0604020202020204"/>
+            </a:endParaRPr>
+          </a:p>
+          <a:p>
+            <a:pPr>
+              <a:spcAft>
+                <a:spcPts val="200"/>
+              </a:spcAft>
+            </a:pPr>
+            <a:endParaRPr sz="1600">
+              <a:solidFill>
+                <a:srgbClr val="333333"/>
+              </a:solidFill>
+              <a:latin typeface="Arial" panose="020B0604020202020204"/>
+            </a:endParaRPr>
+          </a:p>
+        </p:txBody>
+      </p:sp>
+      <p:sp>
+        <p:nvSpPr>
+          <p:cNvPr id="12" name="Rounded Rectangle 11"/>
+          <p:cNvSpPr/>
+          <p:nvPr/>
+        </p:nvSpPr>
+        <p:spPr>
+          <a:xfrm>
+            <a:off x="6035040" y="1005840"/>
+            <a:ext cx="5760720" cy="2286000"/>
+          </a:xfrm>
+          <a:prstGeom prst="roundRect">
+            <a:avLst/>
+          </a:prstGeom>
+          <a:solidFill>
+            <a:srgbClr val="E8F5E9"/>
+          </a:solidFill>
+          <a:ln>
+            <a:noFill/>
+          </a:ln>
+        </p:spPr>
+        <p:style>
+          <a:lnRef idx="1">
+            <a:schemeClr val="accent1"/>
+          </a:lnRef>
+          <a:fillRef idx="3">
+            <a:schemeClr val="accent1"/>
+          </a:fillRef>
+          <a:effectRef idx="2">
+            <a:schemeClr val="accent1"/>
+          </a:effectRef>
+          <a:fontRef idx="minor">
+            <a:schemeClr val="lt1"/>
+          </a:fontRef>
+        </p:style>
+        <p:txBody>
+          <a:bodyPr rtlCol="0" anchor="ctr"/>
+          <a:lstStyle/>
+          <a:p>
+            <a:pPr algn="ctr"/>
+          </a:p>
+        </p:txBody>
+      </p:sp>
+      <p:sp>
+        <p:nvSpPr>
+          <p:cNvPr id="13" name="Rectangle 12"/>
+          <p:cNvSpPr/>
+          <p:nvPr/>
+        </p:nvSpPr>
+        <p:spPr>
+          <a:xfrm>
+            <a:off x="6035040" y="1005840"/>
+            <a:ext cx="5760720" cy="457200"/>
+          </a:xfrm>
+          <a:prstGeom prst="rect">
+            <a:avLst/>
+          </a:prstGeom>
+          <a:solidFill>
+            <a:srgbClr val="2E7D32"/>
+          </a:solidFill>
+          <a:ln>
+            <a:noFill/>
+          </a:ln>
+        </p:spPr>
+        <p:style>
+          <a:lnRef idx="1">
+            <a:schemeClr val="accent1"/>
+          </a:lnRef>
+          <a:fillRef idx="3">
+            <a:schemeClr val="accent1"/>
+          </a:fillRef>
+          <a:effectRef idx="2">
+            <a:schemeClr val="accent1"/>
+          </a:effectRef>
+          <a:fontRef idx="minor">
+            <a:schemeClr val="lt1"/>
+          </a:fontRef>
+        </p:style>
+        <p:txBody>
+          <a:bodyPr rtlCol="0" anchor="ctr"/>
+          <a:lstStyle/>
+          <a:p>
+            <a:pPr algn="ctr"/>
+          </a:p>
+        </p:txBody>
+      </p:sp>
+      <p:sp>
+        <p:nvSpPr>
+          <p:cNvPr id="14" name="TextBox 13"/>
+          <p:cNvSpPr txBox="1"/>
+          <p:nvPr/>
+        </p:nvSpPr>
+        <p:spPr>
+          <a:xfrm>
+            <a:off x="6217920" y="1051560"/>
+            <a:ext cx="5394960" cy="365760"/>
+          </a:xfrm>
+          <a:prstGeom prst="rect">
+            <a:avLst/>
+          </a:prstGeom>
+          <a:noFill/>
+        </p:spPr>
+        <p:txBody>
+          <a:bodyPr wrap="square">
+            <a:spAutoFit/>
+          </a:bodyPr>
+          <a:lstStyle/>
+          <a:p>
+            <a:pPr algn="l"/>
+            <a:r>
+              <a:rPr sz="1800" b="1">
+                <a:solidFill>
+                  <a:srgbClr val="FFFFFF"/>
+                </a:solidFill>
+                <a:latin typeface="Arial" panose="020B0604020202020204"/>
+              </a:rPr>
+              <a:t>课题背景</a:t>
+            </a:r>
+            <a:endParaRPr sz="1800" b="1">
+              <a:solidFill>
+                <a:srgbClr val="FFFFFF"/>
+              </a:solidFill>
+              <a:latin typeface="Arial" panose="020B0604020202020204"/>
+            </a:endParaRPr>
+          </a:p>
+        </p:txBody>
+      </p:sp>
+      <p:sp>
+        <p:nvSpPr>
+          <p:cNvPr id="15" name="TextBox 14"/>
+          <p:cNvSpPr txBox="1"/>
+          <p:nvPr/>
+        </p:nvSpPr>
+        <p:spPr>
+          <a:xfrm>
+            <a:off x="6309360" y="1645920"/>
+            <a:ext cx="5303520" cy="1371600"/>
+          </a:xfrm>
+          <a:prstGeom prst="rect">
+            <a:avLst/>
+          </a:prstGeom>
+          <a:noFill/>
+        </p:spPr>
+        <p:txBody>
+          <a:bodyPr wrap="square">
+            <a:spAutoFit/>
+          </a:bodyPr>
+          <a:lstStyle/>
+          <a:p>
+            <a:pPr>
+              <a:spcAft>
+                <a:spcPts val="200"/>
+              </a:spcAft>
+            </a:pPr>
+            <a:r>
+              <a:rPr sz="1600">
+                <a:solidFill>
+                  <a:srgbClr val="333333"/>
+                </a:solidFill>
+                <a:latin typeface="Arial" panose="020B0604020202020204"/>
+              </a:rPr>
+              <a:t>课题背景</a:t>
+            </a:r>
+            <a:endParaRPr sz="1600">
+              <a:solidFill>
+                <a:srgbClr val="333333"/>
+              </a:solidFill>
+              <a:latin typeface="Arial" panose="020B0604020202020204"/>
+            </a:endParaRPr>
+          </a:p>
+          <a:p>
+            <a:pPr>
+              <a:spcAft>
+                <a:spcPts val="200"/>
+              </a:spcAft>
+            </a:pPr>
+            <a:r>
+              <a:rPr sz="1600">
+                <a:solidFill>
+                  <a:srgbClr val="333333"/>
+                </a:solidFill>
+                <a:latin typeface="Arial" panose="020B0604020202020204"/>
+              </a:rPr>
+              <a:t>课题背景</a:t>
+            </a:r>
+            <a:endParaRPr sz="1600">
+              <a:solidFill>
+                <a:srgbClr val="333333"/>
+              </a:solidFill>
+              <a:latin typeface="Arial" panose="020B0604020202020204"/>
+            </a:endParaRPr>
+          </a:p>
+          <a:p>
+            <a:pPr>
+              <a:spcAft>
+                <a:spcPts val="200"/>
+              </a:spcAft>
+            </a:pPr>
+            <a:r>
+              <a:rPr sz="1600">
+                <a:solidFill>
+                  <a:srgbClr val="333333"/>
+                </a:solidFill>
+                <a:latin typeface="Arial" panose="020B0604020202020204"/>
+              </a:rPr>
+              <a:t>课题背景</a:t>
+            </a:r>
+            <a:endParaRPr sz="1600">
+              <a:solidFill>
+                <a:srgbClr val="333333"/>
+              </a:solidFill>
+              <a:latin typeface="Arial" panose="020B0604020202020204"/>
+            </a:endParaRPr>
+          </a:p>
+        </p:txBody>
+      </p:sp>
+      <p:sp>
+        <p:nvSpPr>
+          <p:cNvPr id="16" name="Rounded Rectangle 15"/>
+          <p:cNvSpPr/>
+          <p:nvPr/>
+        </p:nvSpPr>
+        <p:spPr>
+          <a:xfrm>
+            <a:off x="365760" y="3566160"/>
+            <a:ext cx="11430000" cy="2743200"/>
+          </a:xfrm>
+          <a:prstGeom prst="roundRect">
+            <a:avLst/>
+          </a:prstGeom>
+          <a:solidFill>
+            <a:srgbClr val="E0F0F5"/>
+          </a:solidFill>
+          <a:ln>
+            <a:noFill/>
+          </a:ln>
+        </p:spPr>
+        <p:style>
+          <a:lnRef idx="1">
+            <a:schemeClr val="accent1"/>
+          </a:lnRef>
+          <a:fillRef idx="3">
+            <a:schemeClr val="accent1"/>
+          </a:fillRef>
+          <a:effectRef idx="2">
+            <a:schemeClr val="accent1"/>
+          </a:effectRef>
+          <a:fontRef idx="minor">
+            <a:schemeClr val="lt1"/>
+          </a:fontRef>
+        </p:style>
+        <p:txBody>
+          <a:bodyPr rtlCol="0" anchor="ctr"/>
+          <a:lstStyle/>
+          <a:p>
+            <a:pPr algn="ctr"/>
+          </a:p>
+        </p:txBody>
+      </p:sp>
+      <p:sp>
+        <p:nvSpPr>
+          <p:cNvPr id="17" name="TextBox 16"/>
+          <p:cNvSpPr txBox="1"/>
+          <p:nvPr/>
+        </p:nvSpPr>
+        <p:spPr>
+          <a:xfrm>
+            <a:off x="640080" y="3657600"/>
+            <a:ext cx="4572000" cy="365760"/>
+          </a:xfrm>
+          <a:prstGeom prst="rect">
+            <a:avLst/>
+          </a:prstGeom>
+          <a:noFill/>
+        </p:spPr>
+        <p:txBody>
+          <a:bodyPr wrap="square">
+            <a:spAutoFit/>
+          </a:bodyPr>
+          <a:lstStyle/>
+          <a:p>
+            <a:pPr algn="l"/>
+            <a:r>
+              <a:rPr sz="1800" b="1">
+                <a:solidFill>
+                  <a:srgbClr val="007191"/>
+                </a:solidFill>
+                <a:latin typeface="Arial" panose="020B0604020202020204"/>
+              </a:rPr>
+              <a:t>课题背景</a:t>
+            </a:r>
+            <a:endParaRPr sz="1800" b="1">
+              <a:solidFill>
+                <a:srgbClr val="007191"/>
+              </a:solidFill>
+              <a:latin typeface="Arial" panose="020B0604020202020204"/>
+            </a:endParaRPr>
+          </a:p>
+        </p:txBody>
+      </p:sp>
+      <p:sp>
+        <p:nvSpPr>
+          <p:cNvPr id="18" name="TextBox 17"/>
+          <p:cNvSpPr txBox="1"/>
+          <p:nvPr/>
+        </p:nvSpPr>
+        <p:spPr>
+          <a:xfrm>
+            <a:off x="640080" y="4114800"/>
+            <a:ext cx="10789920" cy="365760"/>
+          </a:xfrm>
+          <a:prstGeom prst="rect">
+            <a:avLst/>
+          </a:prstGeom>
+          <a:noFill/>
+        </p:spPr>
+        <p:txBody>
+          <a:bodyPr wrap="square">
+            <a:spAutoFit/>
+          </a:bodyPr>
+          <a:lstStyle/>
+          <a:p>
+            <a:pPr algn="l"/>
+            <a:r>
+              <a:rPr sz="1600" b="1">
+                <a:solidFill>
+                  <a:srgbClr val="007191"/>
+                </a:solidFill>
+                <a:latin typeface="Arial" panose="020B0604020202020204"/>
+              </a:rPr>
+              <a:t>课题背景</a:t>
+            </a:r>
+            <a:endParaRPr sz="1600" b="1">
+              <a:solidFill>
+                <a:srgbClr val="007191"/>
+              </a:solidFill>
+              <a:latin typeface="Arial" panose="020B0604020202020204"/>
+            </a:endParaRPr>
+          </a:p>
+        </p:txBody>
+      </p:sp>
+      <p:sp>
+        <p:nvSpPr>
+          <p:cNvPr id="19" name="TextBox 18"/>
+          <p:cNvSpPr txBox="1"/>
+          <p:nvPr/>
+        </p:nvSpPr>
+        <p:spPr>
+          <a:xfrm>
+            <a:off x="640080" y="4663440"/>
+            <a:ext cx="4572000" cy="365760"/>
+          </a:xfrm>
+          <a:prstGeom prst="rect">
+            <a:avLst/>
+          </a:prstGeom>
+          <a:noFill/>
+        </p:spPr>
+        <p:txBody>
+          <a:bodyPr wrap="square">
+            <a:spAutoFit/>
+          </a:bodyPr>
+          <a:lstStyle/>
+          <a:p>
+            <a:pPr algn="l"/>
+            <a:r>
+              <a:rPr sz="1600" b="1">
+                <a:solidFill>
+                  <a:srgbClr val="007191"/>
+                </a:solidFill>
+                <a:latin typeface="Arial" panose="020B0604020202020204"/>
+              </a:rPr>
+              <a:t>课题背景</a:t>
+            </a:r>
+            <a:endParaRPr sz="1600" b="1">
+              <a:solidFill>
+                <a:srgbClr val="007191"/>
+              </a:solidFill>
+              <a:latin typeface="Arial" panose="020B0604020202020204"/>
+            </a:endParaRPr>
+          </a:p>
+        </p:txBody>
+      </p:sp>
+    </p:spTree>
+  </p:cSld>
+  <p:clrMapOvr>
+    <a:masterClrMapping/>
+  </p:clrMapOvr>
+</p:sld>
+</file>
+
+<file path=ppt/slides/slide6.xml><?xml version="1.0" encoding="utf-8"?>
+<p:sld xmlns:a="http://schemas.openxmlformats.org/drawingml/2006/main" xmlns:r="http://schemas.openxmlformats.org/officeDocument/2006/relationships" xmlns:p="http://schemas.openxmlformats.org/presentationml/2006/main">
+  <p:cSld>
+    <p:spTree>
+      <p:nvGrpSpPr>
+        <p:cNvPr id="1" name=""/>
+        <p:cNvGrpSpPr/>
+        <p:nvPr/>
+      </p:nvGrpSpPr>
+      <p:grpSpPr/>
+      <p:sp>
+        <p:nvSpPr>
+          <p:cNvPr id="2" name="Rectangle 1"/>
+          <p:cNvSpPr/>
+          <p:nvPr/>
+        </p:nvSpPr>
+        <p:spPr>
+          <a:xfrm>
+            <a:off x="0" y="0"/>
+            <a:ext cx="12188952" cy="6858000"/>
+          </a:xfrm>
+          <a:prstGeom prst="rect">
+            <a:avLst/>
+          </a:prstGeom>
+          <a:solidFill>
+            <a:srgbClr val="FFFFFF"/>
+          </a:solidFill>
+          <a:ln>
+            <a:noFill/>
+          </a:ln>
+        </p:spPr>
+        <p:style>
+          <a:lnRef idx="1">
+            <a:schemeClr val="accent1"/>
+          </a:lnRef>
+          <a:fillRef idx="3">
+            <a:schemeClr val="accent1"/>
+          </a:fillRef>
+          <a:effectRef idx="2">
+            <a:schemeClr val="accent1"/>
+          </a:effectRef>
+          <a:fontRef idx="minor">
+            <a:schemeClr val="lt1"/>
+          </a:fontRef>
+        </p:style>
+        <p:txBody>
+          <a:bodyPr rtlCol="0" anchor="ctr"/>
+          <a:lstStyle/>
+          <a:p>
+            <a:pPr algn="ctr"/>
+          </a:p>
+        </p:txBody>
+      </p:sp>
+      <p:sp>
+        <p:nvSpPr>
+          <p:cNvPr id="3" name="Rectangle 2"/>
+          <p:cNvSpPr/>
+          <p:nvPr/>
+        </p:nvSpPr>
+        <p:spPr>
+          <a:xfrm>
+            <a:off x="0" y="0"/>
+            <a:ext cx="12188952" cy="777240"/>
+          </a:xfrm>
+          <a:prstGeom prst="rect">
+            <a:avLst/>
+          </a:prstGeom>
+          <a:solidFill>
+            <a:srgbClr val="1A1A1A"/>
+          </a:solidFill>
+          <a:ln>
+            <a:noFill/>
+          </a:ln>
+        </p:spPr>
+        <p:style>
+          <a:lnRef idx="1">
+            <a:schemeClr val="accent1"/>
+          </a:lnRef>
+          <a:fillRef idx="3">
+            <a:schemeClr val="accent1"/>
+          </a:fillRef>
+          <a:effectRef idx="2">
+            <a:schemeClr val="accent1"/>
+          </a:effectRef>
+          <a:fontRef idx="minor">
+            <a:schemeClr val="lt1"/>
+          </a:fontRef>
+        </p:style>
+        <p:txBody>
+          <a:bodyPr rtlCol="0" anchor="ctr"/>
+          <a:lstStyle/>
+          <a:p>
+            <a:pPr algn="ctr"/>
+          </a:p>
+        </p:txBody>
+      </p:sp>
+      <p:sp>
+        <p:nvSpPr>
+          <p:cNvPr id="4" name="Rectangle 3"/>
+          <p:cNvSpPr/>
+          <p:nvPr/>
+        </p:nvSpPr>
+        <p:spPr>
+          <a:xfrm>
+            <a:off x="274320" y="201168"/>
+            <a:ext cx="109728" cy="384048"/>
+          </a:xfrm>
+          <a:prstGeom prst="rect">
+            <a:avLst/>
+          </a:prstGeom>
+          <a:solidFill>
+            <a:srgbClr val="E63946"/>
+          </a:solidFill>
+          <a:ln>
+            <a:noFill/>
+          </a:ln>
+        </p:spPr>
+        <p:style>
+          <a:lnRef idx="1">
+            <a:schemeClr val="accent1"/>
+          </a:lnRef>
+          <a:fillRef idx="3">
+            <a:schemeClr val="accent1"/>
+          </a:fillRef>
+          <a:effectRef idx="2">
+            <a:schemeClr val="accent1"/>
+          </a:effectRef>
+          <a:fontRef idx="minor">
+            <a:schemeClr val="lt1"/>
+          </a:fontRef>
+        </p:style>
+        <p:txBody>
+          <a:bodyPr rtlCol="0" anchor="ctr"/>
+          <a:lstStyle/>
+          <a:p>
+            <a:pPr algn="ctr"/>
+          </a:p>
+        </p:txBody>
+      </p:sp>
+      <p:sp>
+        <p:nvSpPr>
+          <p:cNvPr id="5" name="Rectangle 4"/>
+          <p:cNvSpPr/>
+          <p:nvPr/>
+        </p:nvSpPr>
+        <p:spPr>
+          <a:xfrm>
+            <a:off x="457200" y="640080"/>
+            <a:ext cx="11247120" cy="27432"/>
+          </a:xfrm>
+          <a:prstGeom prst="rect">
+            <a:avLst/>
+          </a:prstGeom>
+          <a:solidFill>
+            <a:srgbClr val="E63946"/>
+          </a:solidFill>
+          <a:ln>
+            <a:noFill/>
+          </a:ln>
+        </p:spPr>
+        <p:style>
+          <a:lnRef idx="1">
+            <a:schemeClr val="accent1"/>
+          </a:lnRef>
+          <a:fillRef idx="3">
+            <a:schemeClr val="accent1"/>
+          </a:fillRef>
+          <a:effectRef idx="2">
+            <a:schemeClr val="accent1"/>
+          </a:effectRef>
+          <a:fontRef idx="minor">
+            <a:schemeClr val="lt1"/>
+          </a:fontRef>
+        </p:style>
+        <p:txBody>
+          <a:bodyPr rtlCol="0" anchor="ctr"/>
+          <a:lstStyle/>
+          <a:p>
+            <a:pPr algn="ctr"/>
+          </a:p>
+        </p:txBody>
+      </p:sp>
+      <p:sp>
+        <p:nvSpPr>
+          <p:cNvPr id="6" name="TextBox 5"/>
+          <p:cNvSpPr txBox="1"/>
+          <p:nvPr/>
+        </p:nvSpPr>
+        <p:spPr>
+          <a:xfrm>
+            <a:off x="457200" y="137160"/>
+            <a:ext cx="11247120" cy="502920"/>
+          </a:xfrm>
+          <a:prstGeom prst="rect">
+            <a:avLst/>
+          </a:prstGeom>
+          <a:noFill/>
+        </p:spPr>
+        <p:txBody>
+          <a:bodyPr wrap="square">
+            <a:spAutoFit/>
+          </a:bodyPr>
+          <a:lstStyle/>
+          <a:p>
+            <a:pPr algn="l"/>
+            <a:r>
+              <a:rPr sz="2400" b="1">
+                <a:solidFill>
+                  <a:srgbClr val="E63946"/>
+                </a:solidFill>
+                <a:latin typeface="Arial" panose="020B0604020202020204"/>
+              </a:rPr>
+              <a:t>结果总结</a:t>
+            </a:r>
+            <a:endParaRPr sz="2400" b="1">
+              <a:solidFill>
+                <a:srgbClr val="E63946"/>
+              </a:solidFill>
+              <a:latin typeface="Arial" panose="020B0604020202020204"/>
+            </a:endParaRPr>
+          </a:p>
+        </p:txBody>
+      </p:sp>
+      <p:sp>
+        <p:nvSpPr>
+          <p:cNvPr id="7" name="Rectangle 6"/>
+          <p:cNvSpPr/>
+          <p:nvPr/>
+        </p:nvSpPr>
+        <p:spPr>
+          <a:xfrm>
+            <a:off x="0" y="6400800"/>
+            <a:ext cx="12188952" cy="54864"/>
+          </a:xfrm>
+          <a:prstGeom prst="rect">
+            <a:avLst/>
+          </a:prstGeom>
+          <a:solidFill>
+            <a:srgbClr val="E63946"/>
+          </a:solidFill>
+          <a:ln>
+            <a:noFill/>
+          </a:ln>
+        </p:spPr>
+        <p:style>
+          <a:lnRef idx="1">
+            <a:schemeClr val="accent1"/>
+          </a:lnRef>
+          <a:fillRef idx="3">
+            <a:schemeClr val="accent1"/>
+          </a:fillRef>
+          <a:effectRef idx="2">
+            <a:schemeClr val="accent1"/>
+          </a:effectRef>
+          <a:fontRef idx="minor">
+            <a:schemeClr val="lt1"/>
+          </a:fontRef>
+        </p:style>
+        <p:txBody>
+          <a:bodyPr rtlCol="0" anchor="ctr"/>
+          <a:lstStyle/>
+          <a:p>
+            <a:pPr algn="ctr"/>
+          </a:p>
+        </p:txBody>
+      </p:sp>
+      <p:sp>
+        <p:nvSpPr>
+          <p:cNvPr id="8" name="Rounded Rectangle 7"/>
+          <p:cNvSpPr/>
+          <p:nvPr/>
+        </p:nvSpPr>
+        <p:spPr>
+          <a:xfrm>
+            <a:off x="411480" y="1051560"/>
+            <a:ext cx="3611880" cy="3291840"/>
+          </a:xfrm>
+          <a:prstGeom prst="roundRect">
+            <a:avLst/>
+          </a:prstGeom>
+          <a:solidFill>
+            <a:srgbClr val="E0F0F5"/>
+          </a:solidFill>
+          <a:ln>
+            <a:noFill/>
+          </a:ln>
+        </p:spPr>
+        <p:style>
+          <a:lnRef idx="1">
+            <a:schemeClr val="accent1"/>
+          </a:lnRef>
+          <a:fillRef idx="3">
+            <a:schemeClr val="accent1"/>
+          </a:fillRef>
+          <a:effectRef idx="2">
+            <a:schemeClr val="accent1"/>
+          </a:effectRef>
+          <a:fontRef idx="minor">
+            <a:schemeClr val="lt1"/>
+          </a:fontRef>
+        </p:style>
+        <p:txBody>
+          <a:bodyPr rtlCol="0" anchor="ctr"/>
+          <a:lstStyle/>
+          <a:p>
+            <a:pPr algn="ctr"/>
+          </a:p>
+        </p:txBody>
+      </p:sp>
+      <p:sp>
+        <p:nvSpPr>
+          <p:cNvPr id="9" name="Rectangle 8"/>
+          <p:cNvSpPr/>
+          <p:nvPr/>
+        </p:nvSpPr>
+        <p:spPr>
+          <a:xfrm>
+            <a:off x="411480" y="1051560"/>
+            <a:ext cx="3611880" cy="502920"/>
+          </a:xfrm>
+          <a:prstGeom prst="rect">
+            <a:avLst/>
+          </a:prstGeom>
+          <a:solidFill>
+            <a:srgbClr val="007191"/>
+          </a:solidFill>
+          <a:ln>
+            <a:noFill/>
+          </a:ln>
+        </p:spPr>
+        <p:style>
+          <a:lnRef idx="1">
+            <a:schemeClr val="accent1"/>
+          </a:lnRef>
+          <a:fillRef idx="3">
+            <a:schemeClr val="accent1"/>
+          </a:fillRef>
+          <a:effectRef idx="2">
+            <a:schemeClr val="accent1"/>
+          </a:effectRef>
+          <a:fontRef idx="minor">
+            <a:schemeClr val="lt1"/>
+          </a:fontRef>
+        </p:style>
+        <p:txBody>
+          <a:bodyPr rtlCol="0" anchor="ctr"/>
+          <a:lstStyle/>
+          <a:p>
+            <a:pPr algn="ctr"/>
+          </a:p>
+        </p:txBody>
+      </p:sp>
+      <p:sp>
+        <p:nvSpPr>
+          <p:cNvPr id="10" name="TextBox 9"/>
+          <p:cNvSpPr txBox="1"/>
+          <p:nvPr/>
+        </p:nvSpPr>
+        <p:spPr>
+          <a:xfrm>
+            <a:off x="594360" y="1097280"/>
+            <a:ext cx="3200400" cy="411480"/>
+          </a:xfrm>
+          <a:prstGeom prst="rect">
+            <a:avLst/>
+          </a:prstGeom>
+          <a:noFill/>
+        </p:spPr>
+        <p:txBody>
+          <a:bodyPr wrap="square">
+            <a:spAutoFit/>
+          </a:bodyPr>
+          <a:lstStyle/>
+          <a:p>
+            <a:pPr algn="l"/>
+            <a:r>
+              <a:rPr sz="2000" b="1">
+                <a:solidFill>
+                  <a:srgbClr val="FFFFFF"/>
+                </a:solidFill>
+                <a:latin typeface="Arial" panose="020B0604020202020204"/>
+              </a:rPr>
+              <a:t>结果总结</a:t>
+            </a:r>
+            <a:endParaRPr sz="2000" b="1">
+              <a:solidFill>
+                <a:srgbClr val="FFFFFF"/>
+              </a:solidFill>
+              <a:latin typeface="Arial" panose="020B0604020202020204"/>
+            </a:endParaRPr>
+          </a:p>
+        </p:txBody>
+      </p:sp>
+      <p:sp>
+        <p:nvSpPr>
+          <p:cNvPr id="11" name="TextBox 10"/>
+          <p:cNvSpPr txBox="1"/>
+          <p:nvPr/>
+        </p:nvSpPr>
+        <p:spPr>
+          <a:xfrm>
+            <a:off x="640080" y="1691640"/>
+            <a:ext cx="3108960" cy="2468880"/>
+          </a:xfrm>
+          <a:prstGeom prst="rect">
+            <a:avLst/>
+          </a:prstGeom>
+          <a:noFill/>
+        </p:spPr>
+        <p:txBody>
+          <a:bodyPr wrap="square">
+            <a:spAutoFit/>
+          </a:bodyPr>
+          <a:lstStyle/>
+          <a:p>
+            <a:pPr>
+              <a:spcAft>
+                <a:spcPts val="200"/>
+              </a:spcAft>
+            </a:pPr>
+            <a:r>
+              <a:rPr sz="1600">
+                <a:solidFill>
+                  <a:srgbClr val="333333"/>
+                </a:solidFill>
+                <a:latin typeface="Arial" panose="020B0604020202020204"/>
+              </a:rPr>
+              <a:t>结果总结</a:t>
+            </a:r>
+            <a:endParaRPr sz="1600">
+              <a:solidFill>
+                <a:srgbClr val="333333"/>
+              </a:solidFill>
+              <a:latin typeface="Arial" panose="020B0604020202020204"/>
+            </a:endParaRPr>
+          </a:p>
+        </p:txBody>
+      </p:sp>
+      <p:sp>
+        <p:nvSpPr>
+          <p:cNvPr id="12" name="Rounded Rectangle 11"/>
+          <p:cNvSpPr/>
+          <p:nvPr/>
+        </p:nvSpPr>
+        <p:spPr>
+          <a:xfrm>
+            <a:off x="4270248" y="1051560"/>
+            <a:ext cx="3611880" cy="3291840"/>
+          </a:xfrm>
+          <a:prstGeom prst="roundRect">
+            <a:avLst/>
+          </a:prstGeom>
+          <a:solidFill>
+            <a:srgbClr val="E0F0F5"/>
+          </a:solidFill>
+          <a:ln>
+            <a:noFill/>
+          </a:ln>
+        </p:spPr>
+        <p:style>
+          <a:lnRef idx="1">
+            <a:schemeClr val="accent1"/>
+          </a:lnRef>
+          <a:fillRef idx="3">
+            <a:schemeClr val="accent1"/>
+          </a:fillRef>
+          <a:effectRef idx="2">
+            <a:schemeClr val="accent1"/>
+          </a:effectRef>
+          <a:fontRef idx="minor">
+            <a:schemeClr val="lt1"/>
+          </a:fontRef>
+        </p:style>
+        <p:txBody>
+          <a:bodyPr rtlCol="0" anchor="ctr"/>
+          <a:lstStyle/>
+          <a:p>
+            <a:pPr algn="ctr"/>
+          </a:p>
+        </p:txBody>
+      </p:sp>
+      <p:sp>
+        <p:nvSpPr>
+          <p:cNvPr id="13" name="Rectangle 12"/>
+          <p:cNvSpPr/>
+          <p:nvPr/>
+        </p:nvSpPr>
+        <p:spPr>
+          <a:xfrm>
+            <a:off x="4270248" y="1051560"/>
+            <a:ext cx="3611880" cy="502920"/>
+          </a:xfrm>
+          <a:prstGeom prst="rect">
+            <a:avLst/>
+          </a:prstGeom>
+          <a:solidFill>
+            <a:srgbClr val="007191"/>
+          </a:solidFill>
+          <a:ln>
+            <a:noFill/>
+          </a:ln>
+        </p:spPr>
+        <p:style>
+          <a:lnRef idx="1">
+            <a:schemeClr val="accent1"/>
+          </a:lnRef>
+          <a:fillRef idx="3">
+            <a:schemeClr val="accent1"/>
+          </a:fillRef>
+          <a:effectRef idx="2">
+            <a:schemeClr val="accent1"/>
+          </a:effectRef>
+          <a:fontRef idx="minor">
+            <a:schemeClr val="lt1"/>
+          </a:fontRef>
+        </p:style>
+        <p:txBody>
+          <a:bodyPr rtlCol="0" anchor="ctr"/>
+          <a:lstStyle/>
+          <a:p>
+            <a:pPr algn="ctr"/>
+          </a:p>
+        </p:txBody>
+      </p:sp>
+      <p:sp>
+        <p:nvSpPr>
+          <p:cNvPr id="14" name="TextBox 13"/>
+          <p:cNvSpPr txBox="1"/>
+          <p:nvPr/>
+        </p:nvSpPr>
+        <p:spPr>
+          <a:xfrm>
+            <a:off x="4453128" y="1097280"/>
+            <a:ext cx="3200400" cy="411480"/>
+          </a:xfrm>
+          <a:prstGeom prst="rect">
+            <a:avLst/>
+          </a:prstGeom>
+          <a:noFill/>
+        </p:spPr>
+        <p:txBody>
+          <a:bodyPr wrap="square">
+            <a:spAutoFit/>
+          </a:bodyPr>
+          <a:lstStyle/>
+          <a:p>
+            <a:pPr algn="l"/>
+            <a:r>
+              <a:rPr sz="2000" b="1">
+                <a:solidFill>
+                  <a:srgbClr val="FFFFFF"/>
+                </a:solidFill>
+                <a:latin typeface="Arial" panose="020B0604020202020204"/>
+              </a:rPr>
+              <a:t>结果总结</a:t>
+            </a:r>
+            <a:endParaRPr sz="2000" b="1">
+              <a:solidFill>
+                <a:srgbClr val="FFFFFF"/>
+              </a:solidFill>
+              <a:latin typeface="Arial" panose="020B0604020202020204"/>
+            </a:endParaRPr>
+          </a:p>
+        </p:txBody>
+      </p:sp>
+      <p:sp>
+        <p:nvSpPr>
+          <p:cNvPr id="15" name="TextBox 14"/>
+          <p:cNvSpPr txBox="1"/>
+          <p:nvPr/>
+        </p:nvSpPr>
+        <p:spPr>
+          <a:xfrm>
+            <a:off x="4498848" y="1691640"/>
+            <a:ext cx="3108960" cy="2468880"/>
+          </a:xfrm>
+          <a:prstGeom prst="rect">
+            <a:avLst/>
+          </a:prstGeom>
+          <a:noFill/>
+        </p:spPr>
+        <p:txBody>
+          <a:bodyPr wrap="square">
+            <a:spAutoFit/>
+          </a:bodyPr>
+          <a:lstStyle/>
+          <a:p>
+            <a:pPr>
+              <a:spcAft>
+                <a:spcPts val="200"/>
+              </a:spcAft>
+            </a:pPr>
+            <a:r>
+              <a:rPr sz="1600">
+                <a:solidFill>
+                  <a:srgbClr val="333333"/>
+                </a:solidFill>
+                <a:latin typeface="Arial" panose="020B0604020202020204"/>
+              </a:rPr>
+              <a:t>结果总结</a:t>
+            </a:r>
+            <a:endParaRPr sz="1600">
+              <a:solidFill>
+                <a:srgbClr val="333333"/>
+              </a:solidFill>
+              <a:latin typeface="Arial" panose="020B0604020202020204"/>
+            </a:endParaRPr>
+          </a:p>
+        </p:txBody>
+      </p:sp>
+      <p:sp>
+        <p:nvSpPr>
+          <p:cNvPr id="16" name="Rounded Rectangle 15"/>
+          <p:cNvSpPr/>
+          <p:nvPr/>
+        </p:nvSpPr>
+        <p:spPr>
+          <a:xfrm>
+            <a:off x="8129015" y="1051560"/>
+            <a:ext cx="3611880" cy="3291840"/>
+          </a:xfrm>
+          <a:prstGeom prst="roundRect">
+            <a:avLst/>
+          </a:prstGeom>
+          <a:solidFill>
+            <a:srgbClr val="E0F0F5"/>
+          </a:solidFill>
+          <a:ln>
+            <a:noFill/>
+          </a:ln>
+        </p:spPr>
+        <p:style>
+          <a:lnRef idx="1">
+            <a:schemeClr val="accent1"/>
+          </a:lnRef>
+          <a:fillRef idx="3">
+            <a:schemeClr val="accent1"/>
+          </a:fillRef>
+          <a:effectRef idx="2">
+            <a:schemeClr val="accent1"/>
+          </a:effectRef>
+          <a:fontRef idx="minor">
+            <a:schemeClr val="lt1"/>
+          </a:fontRef>
+        </p:style>
+        <p:txBody>
+          <a:bodyPr rtlCol="0" anchor="ctr"/>
+          <a:lstStyle/>
+          <a:p>
+            <a:pPr algn="ctr"/>
+          </a:p>
+        </p:txBody>
+      </p:sp>
+      <p:sp>
+        <p:nvSpPr>
+          <p:cNvPr id="17" name="Rectangle 16"/>
+          <p:cNvSpPr/>
+          <p:nvPr/>
+        </p:nvSpPr>
+        <p:spPr>
+          <a:xfrm>
+            <a:off x="8129015" y="1051560"/>
+            <a:ext cx="3611880" cy="502920"/>
+          </a:xfrm>
+          <a:prstGeom prst="rect">
+            <a:avLst/>
+          </a:prstGeom>
+          <a:solidFill>
+            <a:srgbClr val="007191"/>
+          </a:solidFill>
+          <a:ln>
+            <a:noFill/>
+          </a:ln>
+        </p:spPr>
+        <p:style>
+          <a:lnRef idx="1">
+            <a:schemeClr val="accent1"/>
+          </a:lnRef>
+          <a:fillRef idx="3">
+            <a:schemeClr val="accent1"/>
+          </a:fillRef>
+          <a:effectRef idx="2">
+            <a:schemeClr val="accent1"/>
+          </a:effectRef>
+          <a:fontRef idx="minor">
+            <a:schemeClr val="lt1"/>
+          </a:fontRef>
+        </p:style>
+        <p:txBody>
+          <a:bodyPr rtlCol="0" anchor="ctr"/>
+          <a:lstStyle/>
+          <a:p>
+            <a:pPr algn="ctr"/>
+          </a:p>
+        </p:txBody>
+      </p:sp>
+      <p:sp>
+        <p:nvSpPr>
+          <p:cNvPr id="18" name="TextBox 17"/>
+          <p:cNvSpPr txBox="1"/>
+          <p:nvPr/>
+        </p:nvSpPr>
+        <p:spPr>
+          <a:xfrm>
+            <a:off x="8311895" y="1097280"/>
+            <a:ext cx="3200400" cy="411480"/>
+          </a:xfrm>
+          <a:prstGeom prst="rect">
+            <a:avLst/>
+          </a:prstGeom>
+          <a:noFill/>
+        </p:spPr>
+        <p:txBody>
+          <a:bodyPr wrap="square">
+            <a:spAutoFit/>
+          </a:bodyPr>
+          <a:lstStyle/>
+          <a:p>
+            <a:pPr algn="l"/>
+            <a:r>
+              <a:rPr sz="2000" b="1">
+                <a:solidFill>
+                  <a:srgbClr val="FFFFFF"/>
+                </a:solidFill>
+                <a:latin typeface="Arial" panose="020B0604020202020204"/>
+              </a:rPr>
+              <a:t>结果总结</a:t>
+            </a:r>
+            <a:endParaRPr sz="2000" b="1">
+              <a:solidFill>
+                <a:srgbClr val="FFFFFF"/>
+              </a:solidFill>
+              <a:latin typeface="Arial" panose="020B0604020202020204"/>
+            </a:endParaRPr>
+          </a:p>
+        </p:txBody>
+      </p:sp>
+      <p:sp>
+        <p:nvSpPr>
+          <p:cNvPr id="19" name="TextBox 18"/>
+          <p:cNvSpPr txBox="1"/>
+          <p:nvPr/>
+        </p:nvSpPr>
+        <p:spPr>
+          <a:xfrm>
+            <a:off x="8357615" y="1691640"/>
+            <a:ext cx="3108960" cy="2468880"/>
+          </a:xfrm>
+          <a:prstGeom prst="rect">
+            <a:avLst/>
+          </a:prstGeom>
+          <a:noFill/>
+        </p:spPr>
+        <p:txBody>
+          <a:bodyPr wrap="square">
+            <a:spAutoFit/>
+          </a:bodyPr>
+          <a:lstStyle/>
+          <a:p>
+            <a:pPr>
+              <a:spcAft>
+                <a:spcPts val="200"/>
+              </a:spcAft>
+            </a:pPr>
+            <a:r>
+              <a:rPr sz="1600">
+                <a:solidFill>
+                  <a:srgbClr val="333333"/>
+                </a:solidFill>
+                <a:latin typeface="Arial" panose="020B0604020202020204"/>
+              </a:rPr>
+              <a:t>结果总结</a:t>
+            </a:r>
+            <a:endParaRPr sz="1600">
+              <a:solidFill>
+                <a:srgbClr val="333333"/>
+              </a:solidFill>
+              <a:latin typeface="Arial" panose="020B0604020202020204"/>
+            </a:endParaRPr>
+          </a:p>
+        </p:txBody>
+      </p:sp>
+      <p:sp>
+        <p:nvSpPr>
+          <p:cNvPr id="20" name="Rounded Rectangle 19"/>
+          <p:cNvSpPr/>
+          <p:nvPr/>
+        </p:nvSpPr>
+        <p:spPr>
+          <a:xfrm>
+            <a:off x="411480" y="4617720"/>
+            <a:ext cx="11338560" cy="1645920"/>
+          </a:xfrm>
+          <a:prstGeom prst="roundRect">
+            <a:avLst/>
+          </a:prstGeom>
+          <a:solidFill>
+            <a:srgbClr val="E0F0F5"/>
+          </a:solidFill>
+          <a:ln>
+            <a:noFill/>
+          </a:ln>
+        </p:spPr>
+        <p:style>
+          <a:lnRef idx="1">
+            <a:schemeClr val="accent1"/>
+          </a:lnRef>
+          <a:fillRef idx="3">
+            <a:schemeClr val="accent1"/>
+          </a:fillRef>
+          <a:effectRef idx="2">
+            <a:schemeClr val="accent1"/>
+          </a:effectRef>
+          <a:fontRef idx="minor">
+            <a:schemeClr val="lt1"/>
+          </a:fontRef>
+        </p:style>
+        <p:txBody>
+          <a:bodyPr rtlCol="0" anchor="ctr"/>
+          <a:lstStyle/>
+          <a:p>
+            <a:pPr algn="ctr"/>
+          </a:p>
+        </p:txBody>
+      </p:sp>
+      <p:sp>
+        <p:nvSpPr>
+          <p:cNvPr id="21" name="TextBox 20"/>
+          <p:cNvSpPr txBox="1"/>
+          <p:nvPr/>
+        </p:nvSpPr>
+        <p:spPr>
+          <a:xfrm>
+            <a:off x="640080" y="4709160"/>
+            <a:ext cx="10881360" cy="365760"/>
+          </a:xfrm>
+          <a:prstGeom prst="rect">
+            <a:avLst/>
+          </a:prstGeom>
+          <a:noFill/>
+        </p:spPr>
+        <p:txBody>
+          <a:bodyPr wrap="square">
+            <a:spAutoFit/>
+          </a:bodyPr>
+          <a:lstStyle/>
+          <a:p>
+            <a:pPr algn="l"/>
+            <a:r>
+              <a:rPr sz="1800" b="1">
+                <a:solidFill>
+                  <a:srgbClr val="007191"/>
+                </a:solidFill>
+                <a:latin typeface="Arial" panose="020B0604020202020204"/>
+              </a:rPr>
+              <a:t>结果总结</a:t>
+            </a:r>
+            <a:endParaRPr sz="1800" b="1">
+              <a:solidFill>
+                <a:srgbClr val="007191"/>
+              </a:solidFill>
+              <a:latin typeface="Arial" panose="020B0604020202020204"/>
+            </a:endParaRPr>
+          </a:p>
+        </p:txBody>
+      </p:sp>
+      <p:sp>
+        <p:nvSpPr>
+          <p:cNvPr id="22" name="TextBox 21"/>
+          <p:cNvSpPr txBox="1"/>
+          <p:nvPr/>
+        </p:nvSpPr>
+        <p:spPr>
+          <a:xfrm>
+            <a:off x="640080" y="5120640"/>
+            <a:ext cx="10881360" cy="1005840"/>
+          </a:xfrm>
+          <a:prstGeom prst="rect">
+            <a:avLst/>
+          </a:prstGeom>
+          <a:noFill/>
+        </p:spPr>
+        <p:txBody>
+          <a:bodyPr wrap="square">
+            <a:spAutoFit/>
+          </a:bodyPr>
+          <a:lstStyle/>
+          <a:p>
+            <a:pPr>
+              <a:spcAft>
+                <a:spcPts val="200"/>
+              </a:spcAft>
+            </a:pPr>
+            <a:r>
+              <a:rPr sz="1600">
+                <a:solidFill>
+                  <a:srgbClr val="333333"/>
+                </a:solidFill>
+                <a:latin typeface="Arial" panose="020B0604020202020204"/>
+              </a:rPr>
+              <a:t>结果总结</a:t>
+            </a:r>
+            <a:endParaRPr sz="1600">
+              <a:solidFill>
+                <a:srgbClr val="333333"/>
+              </a:solidFill>
+              <a:latin typeface="Arial" panose="020B0604020202020204"/>
+            </a:endParaRPr>
           </a:p>
         </p:txBody>
       </p:sp>
@@ -4440,7 +6679,7 @@
 </file>
 
 <file path=ppt/slides/slide8.xml><?xml version="1.0" encoding="utf-8"?>
-<p:sld xmlns:a="http://schemas.openxmlformats.org/drawingml/2006/main" xmlns:p="http://schemas.openxmlformats.org/presentationml/2006/main" xmlns:r="http://schemas.openxmlformats.org/officeDocument/2006/relationships">
+<p:sld xmlns:a="http://schemas.openxmlformats.org/drawingml/2006/main" xmlns:r="http://schemas.openxmlformats.org/officeDocument/2006/relationships" xmlns:p="http://schemas.openxmlformats.org/presentationml/2006/main">
   <p:cSld>
     <p:spTree>
       <p:nvGrpSpPr>
@@ -4464,7 +6703,7 @@
             <a:avLst/>
           </a:prstGeom>
           <a:solidFill>
-            <a:srgbClr val="1A1A1A"/>
+            <a:srgbClr val="FFFFFF"/>
           </a:solidFill>
           <a:ln>
             <a:noFill/>
@@ -4501,13 +6740,13 @@
         <p:spPr>
           <a:xfrm>
             <a:off x="0" y="0"/>
-            <a:ext cx="1097280" cy="6858000"/>
-          </a:xfrm>
-          <a:prstGeom prst="rect">
-            <a:avLst/>
-          </a:prstGeom>
-          <a:solidFill>
-            <a:srgbClr val="E63946"/>
+            <a:ext cx="12188952" cy="777240"/>
+          </a:xfrm>
+          <a:prstGeom prst="rect">
+            <a:avLst/>
+          </a:prstGeom>
+          <a:solidFill>
+            <a:srgbClr val="1A1A1A"/>
           </a:solidFill>
           <a:ln>
             <a:noFill/>
@@ -4537,49 +6776,14 @@
       </p:sp>
       <p:sp>
         <p:nvSpPr>
-          <p:cNvPr id="4" name="TextBox 3"/>
-          <p:cNvSpPr txBox="1"/>
-          <p:nvPr/>
-        </p:nvSpPr>
-        <p:spPr>
-          <a:xfrm>
-            <a:off x="1828800" y="2286000"/>
-            <a:ext cx="9144000" cy="1371600"/>
-          </a:xfrm>
-          <a:prstGeom prst="rect">
-            <a:avLst/>
-          </a:prstGeom>
-          <a:noFill/>
-        </p:spPr>
-        <p:txBody>
-          <a:bodyPr wrap="square">
-            <a:spAutoFit/>
-          </a:bodyPr>
-          <a:lstStyle/>
-          <a:p>
-            <a:pPr algn="l"/>
-            <a:r>
-              <a:rPr sz="7200" b="1">
-                <a:solidFill>
-                  <a:srgbClr val="FFFFFF"/>
-                </a:solidFill>
-                <a:latin typeface="Arial"/>
-              </a:rPr>
-              <a:t>THANKS</a:t>
-            </a:r>
-          </a:p>
-        </p:txBody>
-      </p:sp>
-      <p:sp>
-        <p:nvSpPr>
-          <p:cNvPr id="5" name="Rectangle 4"/>
+          <p:cNvPr id="4" name="Rectangle 3"/>
           <p:cNvSpPr/>
           <p:nvPr/>
         </p:nvSpPr>
         <p:spPr>
           <a:xfrm>
-            <a:off x="1828800" y="3749039"/>
-            <a:ext cx="2743200" cy="54864"/>
+            <a:off x="274320" y="201168"/>
+            <a:ext cx="109728" cy="384048"/>
           </a:xfrm>
           <a:prstGeom prst="rect">
             <a:avLst/>
@@ -4615,49 +6819,14 @@
       </p:sp>
       <p:sp>
         <p:nvSpPr>
-          <p:cNvPr id="6" name="TextBox 5"/>
-          <p:cNvSpPr txBox="1"/>
-          <p:nvPr/>
-        </p:nvSpPr>
-        <p:spPr>
-          <a:xfrm>
-            <a:off x="1828800" y="4114800"/>
-            <a:ext cx="4572000" cy="457200"/>
-          </a:xfrm>
-          <a:prstGeom prst="rect">
-            <a:avLst/>
-          </a:prstGeom>
-          <a:noFill/>
-        </p:spPr>
-        <p:txBody>
-          <a:bodyPr wrap="square">
-            <a:spAutoFit/>
-          </a:bodyPr>
-          <a:lstStyle/>
-          <a:p>
-            <a:pPr algn="l"/>
-            <a:r>
-              <a:rPr sz="2400" b="0">
-                <a:solidFill>
-                  <a:srgbClr val="FFFFFF"/>
-                </a:solidFill>
-                <a:latin typeface="Arial"/>
-              </a:rPr>
-              <a:t>Thank You</a:t>
-            </a:r>
-          </a:p>
-        </p:txBody>
-      </p:sp>
-      <p:sp>
-        <p:nvSpPr>
-          <p:cNvPr id="7" name="Rectangle 6"/>
+          <p:cNvPr id="5" name="Rectangle 4"/>
           <p:cNvSpPr/>
           <p:nvPr/>
         </p:nvSpPr>
         <p:spPr>
           <a:xfrm>
-            <a:off x="0" y="6400800"/>
-            <a:ext cx="12188952" cy="73152"/>
+            <a:off x="457200" y="640080"/>
+            <a:ext cx="11247120" cy="27432"/>
           </a:xfrm>
           <a:prstGeom prst="rect">
             <a:avLst/>
@@ -4688,6 +6857,366 @@
           <a:lstStyle/>
           <a:p>
             <a:pPr algn="ctr"/>
+          </a:p>
+        </p:txBody>
+      </p:sp>
+      <p:sp>
+        <p:nvSpPr>
+          <p:cNvPr id="6" name="TextBox 5"/>
+          <p:cNvSpPr txBox="1"/>
+          <p:nvPr/>
+        </p:nvSpPr>
+        <p:spPr>
+          <a:xfrm>
+            <a:off x="457200" y="137160"/>
+            <a:ext cx="11247120" cy="502920"/>
+          </a:xfrm>
+          <a:prstGeom prst="rect">
+            <a:avLst/>
+          </a:prstGeom>
+          <a:noFill/>
+        </p:spPr>
+        <p:txBody>
+          <a:bodyPr wrap="square">
+            <a:spAutoFit/>
+          </a:bodyPr>
+          <a:lstStyle/>
+          <a:p>
+            <a:pPr algn="l"/>
+            <a:r>
+              <a:rPr sz="2400" b="1">
+                <a:solidFill>
+                  <a:srgbClr val="E63946"/>
+                </a:solidFill>
+                <a:latin typeface="Arial" panose="020B0604020202020204"/>
+              </a:rPr>
+              <a:t>Transformer模型架构</a:t>
+            </a:r>
+            <a:endParaRPr sz="2400" b="1">
+              <a:solidFill>
+                <a:srgbClr val="E63946"/>
+              </a:solidFill>
+              <a:latin typeface="Arial" panose="020B0604020202020204"/>
+            </a:endParaRPr>
+          </a:p>
+        </p:txBody>
+      </p:sp>
+      <p:sp>
+        <p:nvSpPr>
+          <p:cNvPr id="7" name="Rectangle 6"/>
+          <p:cNvSpPr/>
+          <p:nvPr/>
+        </p:nvSpPr>
+        <p:spPr>
+          <a:xfrm>
+            <a:off x="0" y="6400800"/>
+            <a:ext cx="12188952" cy="54864"/>
+          </a:xfrm>
+          <a:prstGeom prst="rect">
+            <a:avLst/>
+          </a:prstGeom>
+          <a:solidFill>
+            <a:srgbClr val="E63946"/>
+          </a:solidFill>
+          <a:ln>
+            <a:noFill/>
+          </a:ln>
+        </p:spPr>
+        <p:style>
+          <a:lnRef idx="1">
+            <a:schemeClr val="accent1"/>
+          </a:lnRef>
+          <a:fillRef idx="3">
+            <a:schemeClr val="accent1"/>
+          </a:fillRef>
+          <a:effectRef idx="2">
+            <a:schemeClr val="accent1"/>
+          </a:effectRef>
+          <a:fontRef idx="minor">
+            <a:schemeClr val="lt1"/>
+          </a:fontRef>
+        </p:style>
+        <p:txBody>
+          <a:bodyPr rtlCol="0" anchor="ctr"/>
+          <a:lstStyle/>
+          <a:p>
+            <a:pPr algn="ctr"/>
+          </a:p>
+        </p:txBody>
+      </p:sp>
+      <p:pic>
+        <p:nvPicPr>
+          <p:cNvPr id="8" name="Picture 7" descr="1A.jpg"/>
+          <p:cNvPicPr>
+            <a:picLocks noChangeAspect="1"/>
+          </p:cNvPicPr>
+          <p:nvPr/>
+        </p:nvPicPr>
+        <p:blipFill>
+          <a:blip r:embed="rId1"/>
+          <a:stretch>
+            <a:fillRect/>
+          </a:stretch>
+        </p:blipFill>
+        <p:spPr>
+          <a:xfrm>
+            <a:off x="274320" y="960120"/>
+            <a:ext cx="5029200" cy="5758950"/>
+          </a:xfrm>
+          <a:prstGeom prst="rect">
+            <a:avLst/>
+          </a:prstGeom>
+        </p:spPr>
+      </p:pic>
+      <p:sp>
+        <p:nvSpPr>
+          <p:cNvPr id="9" name="Oval 8"/>
+          <p:cNvSpPr/>
+          <p:nvPr/>
+        </p:nvSpPr>
+        <p:spPr>
+          <a:xfrm>
+            <a:off x="6217920" y="2423160"/>
+            <a:ext cx="164592" cy="164592"/>
+          </a:xfrm>
+          <a:prstGeom prst="ellipse">
+            <a:avLst/>
+          </a:prstGeom>
+          <a:solidFill>
+            <a:srgbClr val="E63946"/>
+          </a:solidFill>
+          <a:ln>
+            <a:noFill/>
+          </a:ln>
+        </p:spPr>
+        <p:style>
+          <a:lnRef idx="1">
+            <a:schemeClr val="accent1"/>
+          </a:lnRef>
+          <a:fillRef idx="3">
+            <a:schemeClr val="accent1"/>
+          </a:fillRef>
+          <a:effectRef idx="2">
+            <a:schemeClr val="accent1"/>
+          </a:effectRef>
+          <a:fontRef idx="minor">
+            <a:schemeClr val="lt1"/>
+          </a:fontRef>
+        </p:style>
+        <p:txBody>
+          <a:bodyPr rtlCol="0" anchor="ctr"/>
+          <a:lstStyle/>
+          <a:p>
+            <a:pPr algn="ctr"/>
+          </a:p>
+        </p:txBody>
+      </p:sp>
+      <p:sp>
+        <p:nvSpPr>
+          <p:cNvPr id="10" name="TextBox 9"/>
+          <p:cNvSpPr txBox="1"/>
+          <p:nvPr/>
+        </p:nvSpPr>
+        <p:spPr>
+          <a:xfrm>
+            <a:off x="6400800" y="2286000"/>
+            <a:ext cx="5303520" cy="411480"/>
+          </a:xfrm>
+          <a:prstGeom prst="rect">
+            <a:avLst/>
+          </a:prstGeom>
+          <a:noFill/>
+        </p:spPr>
+        <p:txBody>
+          <a:bodyPr wrap="square">
+            <a:spAutoFit/>
+          </a:bodyPr>
+          <a:lstStyle/>
+          <a:p>
+            <a:pPr algn="l"/>
+            <a:r>
+              <a:rPr sz="1600" b="0">
+                <a:solidFill>
+                  <a:srgbClr val="888888"/>
+                </a:solidFill>
+                <a:latin typeface="Arial" panose="020B0604020202020204"/>
+              </a:rPr>
+              <a:t>编码器和解码器均由6层堆叠组成</a:t>
+            </a:r>
+            <a:endParaRPr sz="1600" b="0">
+              <a:solidFill>
+                <a:srgbClr val="888888"/>
+              </a:solidFill>
+              <a:latin typeface="Arial" panose="020B0604020202020204"/>
+            </a:endParaRPr>
+          </a:p>
+        </p:txBody>
+      </p:sp>
+      <p:sp>
+        <p:nvSpPr>
+          <p:cNvPr id="11" name="Oval 10"/>
+          <p:cNvSpPr/>
+          <p:nvPr/>
+        </p:nvSpPr>
+        <p:spPr>
+          <a:xfrm>
+            <a:off x="6217920" y="3337560"/>
+            <a:ext cx="164592" cy="164592"/>
+          </a:xfrm>
+          <a:prstGeom prst="ellipse">
+            <a:avLst/>
+          </a:prstGeom>
+          <a:solidFill>
+            <a:srgbClr val="E63946"/>
+          </a:solidFill>
+          <a:ln>
+            <a:noFill/>
+          </a:ln>
+        </p:spPr>
+        <p:style>
+          <a:lnRef idx="1">
+            <a:schemeClr val="accent1"/>
+          </a:lnRef>
+          <a:fillRef idx="3">
+            <a:schemeClr val="accent1"/>
+          </a:fillRef>
+          <a:effectRef idx="2">
+            <a:schemeClr val="accent1"/>
+          </a:effectRef>
+          <a:fontRef idx="minor">
+            <a:schemeClr val="lt1"/>
+          </a:fontRef>
+        </p:style>
+        <p:txBody>
+          <a:bodyPr rtlCol="0" anchor="ctr"/>
+          <a:lstStyle/>
+          <a:p>
+            <a:pPr algn="ctr"/>
+          </a:p>
+        </p:txBody>
+      </p:sp>
+      <p:sp>
+        <p:nvSpPr>
+          <p:cNvPr id="12" name="TextBox 11"/>
+          <p:cNvSpPr txBox="1"/>
+          <p:nvPr/>
+        </p:nvSpPr>
+        <p:spPr>
+          <a:xfrm>
+            <a:off x="6400800" y="3200400"/>
+            <a:ext cx="5303520" cy="411480"/>
+          </a:xfrm>
+          <a:prstGeom prst="rect">
+            <a:avLst/>
+          </a:prstGeom>
+          <a:noFill/>
+        </p:spPr>
+        <p:txBody>
+          <a:bodyPr wrap="square">
+            <a:spAutoFit/>
+          </a:bodyPr>
+          <a:lstStyle/>
+          <a:p>
+            <a:pPr algn="l"/>
+            <a:r>
+              <a:rPr sz="1600" b="0">
+                <a:solidFill>
+                  <a:srgbClr val="888888"/>
+                </a:solidFill>
+                <a:latin typeface="Arial" panose="020B0604020202020204"/>
+              </a:rPr>
+              <a:t>每层包含多头自注意力和前馈网络</a:t>
+            </a:r>
+            <a:endParaRPr sz="1600" b="0">
+              <a:solidFill>
+                <a:srgbClr val="888888"/>
+              </a:solidFill>
+              <a:latin typeface="Arial" panose="020B0604020202020204"/>
+            </a:endParaRPr>
+          </a:p>
+        </p:txBody>
+      </p:sp>
+      <p:sp>
+        <p:nvSpPr>
+          <p:cNvPr id="13" name="Oval 12"/>
+          <p:cNvSpPr/>
+          <p:nvPr/>
+        </p:nvSpPr>
+        <p:spPr>
+          <a:xfrm>
+            <a:off x="6217920" y="4251960"/>
+            <a:ext cx="164592" cy="164592"/>
+          </a:xfrm>
+          <a:prstGeom prst="ellipse">
+            <a:avLst/>
+          </a:prstGeom>
+          <a:solidFill>
+            <a:srgbClr val="E63946"/>
+          </a:solidFill>
+          <a:ln>
+            <a:noFill/>
+          </a:ln>
+        </p:spPr>
+        <p:style>
+          <a:lnRef idx="1">
+            <a:schemeClr val="accent1"/>
+          </a:lnRef>
+          <a:fillRef idx="3">
+            <a:schemeClr val="accent1"/>
+          </a:fillRef>
+          <a:effectRef idx="2">
+            <a:schemeClr val="accent1"/>
+          </a:effectRef>
+          <a:fontRef idx="minor">
+            <a:schemeClr val="lt1"/>
+          </a:fontRef>
+        </p:style>
+        <p:txBody>
+          <a:bodyPr rtlCol="0" anchor="ctr"/>
+          <a:lstStyle/>
+          <a:p>
+            <a:pPr algn="ctr"/>
+          </a:p>
+        </p:txBody>
+      </p:sp>
+      <p:sp>
+        <p:nvSpPr>
+          <p:cNvPr id="14" name="TextBox 13"/>
+          <p:cNvSpPr txBox="1"/>
+          <p:nvPr/>
+        </p:nvSpPr>
+        <p:spPr>
+          <a:xfrm>
+            <a:off x="6400800" y="4114800"/>
+            <a:ext cx="5303520" cy="411480"/>
+          </a:xfrm>
+          <a:prstGeom prst="rect">
+            <a:avLst/>
+          </a:prstGeom>
+          <a:noFill/>
+        </p:spPr>
+        <p:txBody>
+          <a:bodyPr wrap="square">
+            <a:spAutoFit/>
+          </a:bodyPr>
+          <a:lstStyle/>
+          <a:p>
+            <a:pPr algn="l"/>
+            <a:r>
+              <a:rPr sz="1600" b="0">
+                <a:solidFill>
+                  <a:srgbClr val="888888"/>
+                </a:solidFill>
+                <a:latin typeface="Arial" panose="020B0604020202020204"/>
+              </a:rPr>
+              <a:t>残差连接和层归一化确保训练稳定</a:t>
+            </a:r>
+            <a:endParaRPr sz="1600" b="0">
+              <a:solidFill>
+                <a:srgbClr val="888888"/>
+              </a:solidFill>
+              <a:latin typeface="Arial" panose="020B0604020202020204"/>
+            </a:endParaRPr>
           </a:p>
         </p:txBody>
       </p:sp>
@@ -5015,6 +7544,10 @@
       </a:style>
     </a:lnDef>
   </a:objectDefaults>
-  <a:extraClrSchemeLst/>
+  <a:extLst>
+    <a:ext uri="{05A4C25C-085E-4340-85A3-A5531E510DB2}">
+      <thm15:themeFamily xmlns:thm15="http://schemas.microsoft.com/office/thememl/2012/main" name="Office Theme" id="{62F939B6-93AF-4DB8-9C6B-D6C7DFDC589F}" vid="{4A3C46E8-61CC-4603-A589-7422A47A8E4A}"/>
+    </a:ext>
+  </a:extLst>
 </a:theme>
 </file>
</xml_diff>